<commit_message>
Add feedback without reframing AER deck
</commit_message>
<xml_diff>
--- a/submission/cluster2_digital_first_round_20260828/presentation/cluster2_digital_first_round_20260828.pptx
+++ b/submission/cluster2_digital_first_round_20260828/presentation/cluster2_digital_first_round_20260828.pptx
@@ -4611,7 +4611,7 @@
           <a:lstStyle/>
           <a:p>
             <a:pPr algn="ctr">
-              <a:defRPr sz="1800" b="1">
+              <a:defRPr sz="1700" b="1">
                 <a:solidFill>
                   <a:srgbClr val="F6F9FC"/>
                 </a:solidFill>
@@ -4619,14 +4619,50 @@
               </a:defRPr>
             </a:pPr>
             <a:r>
-              <a:t>final-trace 직접 비교  ·  CAV RTL  ·  activity power  ·  signoff</a:t>
-            </a:r>
-          </a:p>
-        </p:txBody>
-      </p:sp>
-      <p:sp>
-        <p:nvSpPr>
-          <p:cNvPr id="24" name="Rounded Rectangle 23"/>
+              <a:t>repeat-flag  ·  polarity→CAV full replay/RTL  ·  activity power  ·  exact Fmax</a:t>
+            </a:r>
+          </a:p>
+        </p:txBody>
+      </p:sp>
+      <p:sp>
+        <p:nvSpPr>
+          <p:cNvPr id="24" name="TextBox 23"/>
+          <p:cNvSpPr txBox="1"/>
+          <p:nvPr/>
+        </p:nvSpPr>
+        <p:spPr>
+          <a:xfrm>
+            <a:off x="1965960" y="4553712"/>
+            <a:ext cx="8732520" cy="182880"/>
+          </a:xfrm>
+          <a:prstGeom prst="rect">
+            <a:avLst/>
+          </a:prstGeom>
+          <a:noFill/>
+        </p:spPr>
+        <p:txBody>
+          <a:bodyPr wrap="square" anchor="t" lIns="18288" rIns="18288" tIns="9144" bIns="9144">
+            <a:spAutoFit/>
+          </a:bodyPr>
+          <a:lstStyle/>
+          <a:p>
+            <a:pPr algn="ctr">
+              <a:defRPr sz="900" b="1">
+                <a:solidFill>
+                  <a:srgbClr val="FFB746"/>
+                </a:solidFill>
+                <a:latin typeface="Malgun Gothic"/>
+              </a:defRPr>
+            </a:pPr>
+            <a:r>
+              <a:t>row-trim −14.29%는 기본 Cluster2 전용 · steal_buf에는 적용 불가</a:t>
+            </a:r>
+          </a:p>
+        </p:txBody>
+      </p:sp>
+      <p:sp>
+        <p:nvSpPr>
+          <p:cNvPr id="25" name="Rounded Rectangle 24"/>
           <p:cNvSpPr/>
           <p:nvPr/>
         </p:nvSpPr>
@@ -4669,7 +4705,7 @@
       </p:sp>
       <p:sp>
         <p:nvSpPr>
-          <p:cNvPr id="25" name="TextBox 24"/>
+          <p:cNvPr id="26" name="TextBox 25"/>
           <p:cNvSpPr txBox="1"/>
           <p:nvPr/>
         </p:nvSpPr>
@@ -4705,7 +4741,7 @@
       </p:sp>
       <p:sp>
         <p:nvSpPr>
-          <p:cNvPr id="26" name="Rectangle 25"/>
+          <p:cNvPr id="27" name="Rectangle 26"/>
           <p:cNvSpPr/>
           <p:nvPr/>
         </p:nvSpPr>
@@ -4748,7 +4784,7 @@
       </p:sp>
       <p:sp>
         <p:nvSpPr>
-          <p:cNvPr id="27" name="Rounded Rectangle 26"/>
+          <p:cNvPr id="28" name="Rounded Rectangle 27"/>
           <p:cNvSpPr/>
           <p:nvPr/>
         </p:nvSpPr>
@@ -4791,7 +4827,7 @@
       </p:sp>
       <p:sp>
         <p:nvSpPr>
-          <p:cNvPr id="28" name="TextBox 27"/>
+          <p:cNvPr id="29" name="TextBox 28"/>
           <p:cNvSpPr txBox="1"/>
           <p:nvPr/>
         </p:nvSpPr>
@@ -4827,7 +4863,7 @@
       </p:sp>
       <p:sp>
         <p:nvSpPr>
-          <p:cNvPr id="29" name="TextBox 28"/>
+          <p:cNvPr id="30" name="TextBox 29"/>
           <p:cNvSpPr txBox="1"/>
           <p:nvPr/>
         </p:nvSpPr>
@@ -4863,7 +4899,7 @@
       </p:sp>
       <p:sp>
         <p:nvSpPr>
-          <p:cNvPr id="30" name="Rectangle 29"/>
+          <p:cNvPr id="31" name="Rectangle 30"/>
           <p:cNvSpPr/>
           <p:nvPr/>
         </p:nvSpPr>
@@ -5083,7 +5119,7 @@
               </a:defRPr>
             </a:pPr>
             <a:r>
-              <a:t>우리 AER이 겨냥한 병목은 네 가지다</a:t>
+              <a:t>Ryu의 6문제에서 우리가 구체화한 네 RTL 병목</a:t>
             </a:r>
           </a:p>
         </p:txBody>
@@ -5162,7 +5198,7 @@
               </a:defRPr>
             </a:pPr>
             <a:r>
-              <a:t>Source: final polarity RTL contract and bottleneck audit</a:t>
+              <a:t>Source: Ryu CVPRW 2019 · final polarity RTL contract · bottleneck audit</a:t>
             </a:r>
           </a:p>
         </p:txBody>
@@ -5205,7 +5241,43 @@
       </p:sp>
       <p:sp>
         <p:nvSpPr>
-          <p:cNvPr id="9" name="Rounded Rectangle 8"/>
+          <p:cNvPr id="9" name="TextBox 8"/>
+          <p:cNvSpPr txBox="1"/>
+          <p:nvPr/>
+        </p:nvSpPr>
+        <p:spPr>
+          <a:xfrm>
+            <a:off x="841248" y="905256"/>
+            <a:ext cx="10515600" cy="182880"/>
+          </a:xfrm>
+          <a:prstGeom prst="rect">
+            <a:avLst/>
+          </a:prstGeom>
+          <a:noFill/>
+        </p:spPr>
+        <p:txBody>
+          <a:bodyPr wrap="square" anchor="t" lIns="18288" rIns="18288" tIns="9144" bIns="9144">
+            <a:spAutoFit/>
+          </a:bodyPr>
+          <a:lstStyle/>
+          <a:p>
+            <a:pPr algn="ctr">
+              <a:defRPr sz="900" b="1">
+                <a:solidFill>
+                  <a:srgbClr val="ACC2D6"/>
+                </a:solidFill>
+                <a:latin typeface="Malgun Gothic"/>
+              </a:defRPr>
+            </a:pPr>
+            <a:r>
+              <a:t>Ryu: ① 주소 overhead  ② bandwidth  ③ arbitration latency  ④ unfairness  ⑤ timestamp  ⑥ motion artifact</a:t>
+            </a:r>
+          </a:p>
+        </p:txBody>
+      </p:sp>
+      <p:sp>
+        <p:nvSpPr>
+          <p:cNvPr id="10" name="Rounded Rectangle 9"/>
           <p:cNvSpPr/>
           <p:nvPr/>
         </p:nvSpPr>
@@ -5250,7 +5322,7 @@
       </p:sp>
       <p:sp>
         <p:nvSpPr>
-          <p:cNvPr id="10" name="TextBox 9"/>
+          <p:cNvPr id="11" name="TextBox 10"/>
           <p:cNvSpPr txBox="1"/>
           <p:nvPr/>
         </p:nvSpPr>
@@ -5286,7 +5358,7 @@
       </p:sp>
       <p:sp>
         <p:nvSpPr>
-          <p:cNvPr id="11" name="TextBox 10"/>
+          <p:cNvPr id="12" name="TextBox 11"/>
           <p:cNvSpPr txBox="1"/>
           <p:nvPr/>
         </p:nvSpPr>
@@ -5322,7 +5394,7 @@
       </p:sp>
       <p:sp>
         <p:nvSpPr>
-          <p:cNvPr id="12" name="TextBox 11"/>
+          <p:cNvPr id="13" name="TextBox 12"/>
           <p:cNvSpPr txBox="1"/>
           <p:nvPr/>
         </p:nvSpPr>
@@ -5358,7 +5430,7 @@
       </p:sp>
       <p:sp>
         <p:nvSpPr>
-          <p:cNvPr id="13" name="Rounded Rectangle 12"/>
+          <p:cNvPr id="14" name="Rounded Rectangle 13"/>
           <p:cNvSpPr/>
           <p:nvPr/>
         </p:nvSpPr>
@@ -5403,7 +5475,7 @@
       </p:sp>
       <p:sp>
         <p:nvSpPr>
-          <p:cNvPr id="14" name="TextBox 13"/>
+          <p:cNvPr id="15" name="TextBox 14"/>
           <p:cNvSpPr txBox="1"/>
           <p:nvPr/>
         </p:nvSpPr>
@@ -5439,7 +5511,7 @@
       </p:sp>
       <p:sp>
         <p:nvSpPr>
-          <p:cNvPr id="15" name="TextBox 14"/>
+          <p:cNvPr id="16" name="TextBox 15"/>
           <p:cNvSpPr txBox="1"/>
           <p:nvPr/>
         </p:nvSpPr>
@@ -5475,7 +5547,7 @@
       </p:sp>
       <p:sp>
         <p:nvSpPr>
-          <p:cNvPr id="16" name="TextBox 15"/>
+          <p:cNvPr id="17" name="TextBox 16"/>
           <p:cNvSpPr txBox="1"/>
           <p:nvPr/>
         </p:nvSpPr>
@@ -5511,7 +5583,7 @@
       </p:sp>
       <p:sp>
         <p:nvSpPr>
-          <p:cNvPr id="17" name="Rounded Rectangle 16"/>
+          <p:cNvPr id="18" name="Rounded Rectangle 17"/>
           <p:cNvSpPr/>
           <p:nvPr/>
         </p:nvSpPr>
@@ -5556,7 +5628,7 @@
       </p:sp>
       <p:sp>
         <p:nvSpPr>
-          <p:cNvPr id="18" name="TextBox 17"/>
+          <p:cNvPr id="19" name="TextBox 18"/>
           <p:cNvSpPr txBox="1"/>
           <p:nvPr/>
         </p:nvSpPr>
@@ -5592,7 +5664,7 @@
       </p:sp>
       <p:sp>
         <p:nvSpPr>
-          <p:cNvPr id="19" name="TextBox 18"/>
+          <p:cNvPr id="20" name="TextBox 19"/>
           <p:cNvSpPr txBox="1"/>
           <p:nvPr/>
         </p:nvSpPr>
@@ -5628,7 +5700,7 @@
       </p:sp>
       <p:sp>
         <p:nvSpPr>
-          <p:cNvPr id="20" name="TextBox 19"/>
+          <p:cNvPr id="21" name="TextBox 20"/>
           <p:cNvSpPr txBox="1"/>
           <p:nvPr/>
         </p:nvSpPr>
@@ -5664,7 +5736,7 @@
       </p:sp>
       <p:sp>
         <p:nvSpPr>
-          <p:cNvPr id="21" name="Rounded Rectangle 20"/>
+          <p:cNvPr id="22" name="Rounded Rectangle 21"/>
           <p:cNvSpPr/>
           <p:nvPr/>
         </p:nvSpPr>
@@ -5709,7 +5781,7 @@
       </p:sp>
       <p:sp>
         <p:nvSpPr>
-          <p:cNvPr id="22" name="TextBox 21"/>
+          <p:cNvPr id="23" name="TextBox 22"/>
           <p:cNvSpPr txBox="1"/>
           <p:nvPr/>
         </p:nvSpPr>
@@ -5745,7 +5817,7 @@
       </p:sp>
       <p:sp>
         <p:nvSpPr>
-          <p:cNvPr id="23" name="TextBox 22"/>
+          <p:cNvPr id="24" name="TextBox 23"/>
           <p:cNvSpPr txBox="1"/>
           <p:nvPr/>
         </p:nvSpPr>
@@ -5781,7 +5853,7 @@
       </p:sp>
       <p:sp>
         <p:nvSpPr>
-          <p:cNvPr id="24" name="TextBox 23"/>
+          <p:cNvPr id="25" name="TextBox 24"/>
           <p:cNvSpPr txBox="1"/>
           <p:nvPr/>
         </p:nvSpPr>
@@ -5817,7 +5889,7 @@
       </p:sp>
       <p:sp>
         <p:nvSpPr>
-          <p:cNvPr id="25" name="Rounded Rectangle 24"/>
+          <p:cNvPr id="26" name="Rounded Rectangle 25"/>
           <p:cNvSpPr/>
           <p:nvPr/>
         </p:nvSpPr>
@@ -5860,7 +5932,7 @@
       </p:sp>
       <p:sp>
         <p:nvSpPr>
-          <p:cNvPr id="26" name="TextBox 25"/>
+          <p:cNvPr id="27" name="TextBox 26"/>
           <p:cNvSpPr txBox="1"/>
           <p:nvPr/>
         </p:nvSpPr>
@@ -5889,14 +5961,14 @@
               </a:defRPr>
             </a:pPr>
             <a:r>
-              <a:t>대역폭 · buffer · 자원 활용 · metadata 정렬이 서로 다른 병목으로 연결된다</a:t>
-            </a:r>
-          </a:p>
-        </p:txBody>
-      </p:sp>
-      <p:sp>
-        <p:nvSpPr>
-          <p:cNvPr id="27" name="Rectangle 26"/>
+              <a:t>직접 개선 ②③④ · 부분 대응 ①⑥ · HOLD ⑤ — 이를 네 RTL 병목으로 구체화</a:t>
+            </a:r>
+          </a:p>
+        </p:txBody>
+      </p:sp>
+      <p:sp>
+        <p:nvSpPr>
+          <p:cNvPr id="28" name="Rectangle 27"/>
           <p:cNvSpPr/>
           <p:nvPr/>
         </p:nvSpPr>
@@ -5939,7 +6011,7 @@
       </p:sp>
       <p:sp>
         <p:nvSpPr>
-          <p:cNvPr id="28" name="Rounded Rectangle 27"/>
+          <p:cNvPr id="29" name="Rounded Rectangle 28"/>
           <p:cNvSpPr/>
           <p:nvPr/>
         </p:nvSpPr>
@@ -5982,7 +6054,7 @@
       </p:sp>
       <p:sp>
         <p:nvSpPr>
-          <p:cNvPr id="29" name="TextBox 28"/>
+          <p:cNvPr id="30" name="TextBox 29"/>
           <p:cNvSpPr txBox="1"/>
           <p:nvPr/>
         </p:nvSpPr>
@@ -6018,7 +6090,7 @@
       </p:sp>
       <p:sp>
         <p:nvSpPr>
-          <p:cNvPr id="30" name="TextBox 29"/>
+          <p:cNvPr id="31" name="TextBox 30"/>
           <p:cNvSpPr txBox="1"/>
           <p:nvPr/>
         </p:nvSpPr>
@@ -6047,14 +6119,14 @@
               </a:defRPr>
             </a:pPr>
             <a:r>
-              <a:t>우리 AER이 겨냥한 병목은 네 가지다</a:t>
-            </a:r>
-          </a:p>
-        </p:txBody>
-      </p:sp>
-      <p:sp>
-        <p:nvSpPr>
-          <p:cNvPr id="31" name="Rectangle 30"/>
+              <a:t>Ryu의 6문제에서 우리가 구체화한 네 RTL 병목</a:t>
+            </a:r>
+          </a:p>
+        </p:txBody>
+      </p:sp>
+      <p:sp>
+        <p:nvSpPr>
+          <p:cNvPr id="32" name="Rectangle 31"/>
           <p:cNvSpPr/>
           <p:nvPr/>
         </p:nvSpPr>
@@ -11740,7 +11812,43 @@
       </p:sp>
       <p:sp>
         <p:nvSpPr>
-          <p:cNvPr id="44" name="Rounded Rectangle 43"/>
+          <p:cNvPr id="44" name="TextBox 43"/>
+          <p:cNvSpPr txBox="1"/>
+          <p:nvPr/>
+        </p:nvSpPr>
+        <p:spPr>
+          <a:xfrm>
+            <a:off x="1024128" y="5285232"/>
+            <a:ext cx="10149840" cy="182880"/>
+          </a:xfrm>
+          <a:prstGeom prst="rect">
+            <a:avLst/>
+          </a:prstGeom>
+          <a:noFill/>
+        </p:spPr>
+        <p:txBody>
+          <a:bodyPr wrap="square" anchor="t" lIns="18288" rIns="18288" tIns="9144" bIns="9144">
+            <a:spAutoFit/>
+          </a:bodyPr>
+          <a:lstStyle/>
+          <a:p>
+            <a:pPr algn="ctr">
+              <a:defRPr sz="900" b="1">
+                <a:solidFill>
+                  <a:srgbClr val="FFB746"/>
+                </a:solidFill>
+                <a:latin typeface="Malgun Gothic"/>
+              </a:defRPr>
+            </a:pPr>
+            <a:r>
+              <a:t>주소 overhead 후속: row-trim −14.29%(기본 Cluster2 전용)  |  repeat-flag −15.61%(steal_buf 적용 가능)</a:t>
+            </a:r>
+          </a:p>
+        </p:txBody>
+      </p:sp>
+      <p:sp>
+        <p:nvSpPr>
+          <p:cNvPr id="45" name="Rounded Rectangle 44"/>
           <p:cNvSpPr/>
           <p:nvPr/>
         </p:nvSpPr>
@@ -11783,7 +11891,7 @@
       </p:sp>
       <p:sp>
         <p:nvSpPr>
-          <p:cNvPr id="45" name="TextBox 44"/>
+          <p:cNvPr id="46" name="TextBox 45"/>
           <p:cNvSpPr txBox="1"/>
           <p:nvPr/>
         </p:nvSpPr>
@@ -11819,7 +11927,7 @@
       </p:sp>
       <p:sp>
         <p:nvSpPr>
-          <p:cNvPr id="46" name="Rectangle 45"/>
+          <p:cNvPr id="47" name="Rectangle 46"/>
           <p:cNvSpPr/>
           <p:nvPr/>
         </p:nvSpPr>
@@ -11862,7 +11970,7 @@
       </p:sp>
       <p:sp>
         <p:nvSpPr>
-          <p:cNvPr id="47" name="Rounded Rectangle 46"/>
+          <p:cNvPr id="48" name="Rounded Rectangle 47"/>
           <p:cNvSpPr/>
           <p:nvPr/>
         </p:nvSpPr>
@@ -11905,7 +12013,7 @@
       </p:sp>
       <p:sp>
         <p:nvSpPr>
-          <p:cNvPr id="48" name="TextBox 47"/>
+          <p:cNvPr id="49" name="TextBox 48"/>
           <p:cNvSpPr txBox="1"/>
           <p:nvPr/>
         </p:nvSpPr>
@@ -11941,7 +12049,7 @@
       </p:sp>
       <p:sp>
         <p:nvSpPr>
-          <p:cNvPr id="49" name="TextBox 48"/>
+          <p:cNvPr id="50" name="TextBox 49"/>
           <p:cNvSpPr txBox="1"/>
           <p:nvPr/>
         </p:nvSpPr>
@@ -11977,7 +12085,7 @@
       </p:sp>
       <p:sp>
         <p:nvSpPr>
-          <p:cNvPr id="50" name="Rectangle 49"/>
+          <p:cNvPr id="51" name="Rectangle 50"/>
           <p:cNvSpPr/>
           <p:nvPr/>
         </p:nvSpPr>
@@ -13474,6 +13582,87 @@
         </p:nvSpPr>
         <p:spPr>
           <a:xfrm>
+            <a:off x="1874519" y="4965192"/>
+            <a:ext cx="8458200" cy="502920"/>
+          </a:xfrm>
+          <a:prstGeom prst="roundRect">
+            <a:avLst/>
+          </a:prstGeom>
+          <a:solidFill>
+            <a:srgbClr val="12304C"/>
+          </a:solidFill>
+          <a:ln w="19050">
+            <a:solidFill>
+              <a:srgbClr val="37CD85"/>
+            </a:solidFill>
+          </a:ln>
+        </p:spPr>
+        <p:style>
+          <a:lnRef idx="1">
+            <a:schemeClr val="accent1"/>
+          </a:lnRef>
+          <a:fillRef idx="3">
+            <a:schemeClr val="accent1"/>
+          </a:fillRef>
+          <a:effectRef idx="2">
+            <a:schemeClr val="accent1"/>
+          </a:effectRef>
+          <a:fontRef idx="minor">
+            <a:schemeClr val="lt1"/>
+          </a:fontRef>
+        </p:style>
+        <p:txBody>
+          <a:bodyPr rtlCol="0" anchor="ctr"/>
+          <a:lstStyle/>
+          <a:p>
+            <a:pPr algn="ctr"/>
+          </a:p>
+        </p:txBody>
+      </p:sp>
+      <p:sp>
+        <p:nvSpPr>
+          <p:cNvPr id="40" name="TextBox 39"/>
+          <p:cNvSpPr txBox="1"/>
+          <p:nvPr/>
+        </p:nvSpPr>
+        <p:spPr>
+          <a:xfrm>
+            <a:off x="2084831" y="5102352"/>
+            <a:ext cx="8037575" cy="219456"/>
+          </a:xfrm>
+          <a:prstGeom prst="rect">
+            <a:avLst/>
+          </a:prstGeom>
+          <a:noFill/>
+        </p:spPr>
+        <p:txBody>
+          <a:bodyPr wrap="square" anchor="t" lIns="18288" rIns="18288" tIns="9144" bIns="9144">
+            <a:spAutoFit/>
+          </a:bodyPr>
+          <a:lstStyle/>
+          <a:p>
+            <a:pPr algn="ctr">
+              <a:defRPr sz="1300" b="1">
+                <a:solidFill>
+                  <a:srgbClr val="37CD85"/>
+                </a:solidFill>
+                <a:latin typeface="Malgun Gothic"/>
+              </a:defRPr>
+            </a:pPr>
+            <a:r>
+              <a:t>추가 핵심: 기본 Cluster2 11.52% → steal_buf 0.47%  ·  loss 12,259 → 502  ·  24.42배 감소</a:t>
+            </a:r>
+          </a:p>
+        </p:txBody>
+      </p:sp>
+      <p:sp>
+        <p:nvSpPr>
+          <p:cNvPr id="41" name="Rounded Rectangle 40"/>
+          <p:cNvSpPr/>
+          <p:nvPr/>
+        </p:nvSpPr>
+        <p:spPr>
+          <a:xfrm>
             <a:off x="713232" y="5669280"/>
             <a:ext cx="10771632" cy="566928"/>
           </a:xfrm>
@@ -13511,7 +13700,7 @@
       </p:sp>
       <p:sp>
         <p:nvSpPr>
-          <p:cNvPr id="40" name="TextBox 39"/>
+          <p:cNvPr id="42" name="TextBox 41"/>
           <p:cNvSpPr txBox="1"/>
           <p:nvPr/>
         </p:nvSpPr>
@@ -13540,21 +13729,21 @@
               </a:defRPr>
             </a:pPr>
             <a:r>
-              <a:t>구조군 비교 결과: accepted +15,928 events  =  overrun 15,928건 감소</a:t>
-            </a:r>
-          </a:p>
-        </p:txBody>
-      </p:sp>
-      <p:sp>
-        <p:nvSpPr>
-          <p:cNvPr id="41" name="TextBox 40"/>
-          <p:cNvSpPr txBox="1"/>
-          <p:nvPr/>
-        </p:nvSpPr>
-        <p:spPr>
-          <a:xfrm>
-            <a:off x="1097280" y="6318504"/>
-            <a:ext cx="10012680" cy="155448"/>
+              <a:t>기본 구조의 대역폭 개선 위에 depth-2·steal이 재발화/불균형 손실을 더 줄였다</a:t>
+            </a:r>
+          </a:p>
+        </p:txBody>
+      </p:sp>
+      <p:sp>
+        <p:nvSpPr>
+          <p:cNvPr id="43" name="TextBox 42"/>
+          <p:cNvSpPr txBox="1"/>
+          <p:nvPr/>
+        </p:nvSpPr>
+        <p:spPr>
+          <a:xfrm>
+            <a:off x="1097280" y="5486400"/>
+            <a:ext cx="10012680" cy="137160"/>
           </a:xfrm>
           <a:prstGeom prst="rect">
             <a:avLst/>
@@ -13583,7 +13772,7 @@
       </p:sp>
       <p:sp>
         <p:nvSpPr>
-          <p:cNvPr id="42" name="Rectangle 41"/>
+          <p:cNvPr id="44" name="Rectangle 43"/>
           <p:cNvSpPr/>
           <p:nvPr/>
         </p:nvSpPr>
@@ -13626,7 +13815,7 @@
       </p:sp>
       <p:sp>
         <p:nvSpPr>
-          <p:cNvPr id="43" name="Rounded Rectangle 42"/>
+          <p:cNvPr id="45" name="Rounded Rectangle 44"/>
           <p:cNvSpPr/>
           <p:nvPr/>
         </p:nvSpPr>
@@ -13669,7 +13858,7 @@
       </p:sp>
       <p:sp>
         <p:nvSpPr>
-          <p:cNvPr id="44" name="TextBox 43"/>
+          <p:cNvPr id="46" name="TextBox 45"/>
           <p:cNvSpPr txBox="1"/>
           <p:nvPr/>
         </p:nvSpPr>
@@ -13705,7 +13894,7 @@
       </p:sp>
       <p:sp>
         <p:nvSpPr>
-          <p:cNvPr id="45" name="TextBox 44"/>
+          <p:cNvPr id="47" name="TextBox 46"/>
           <p:cNvSpPr txBox="1"/>
           <p:nvPr/>
         </p:nvSpPr>
@@ -13741,7 +13930,7 @@
       </p:sp>
       <p:sp>
         <p:nvSpPr>
-          <p:cNvPr id="46" name="Rectangle 45"/>
+          <p:cNvPr id="48" name="Rectangle 47"/>
           <p:cNvSpPr/>
           <p:nvPr/>
         </p:nvSpPr>
@@ -14836,8 +15025,8 @@
         </p:nvSpPr>
         <p:spPr>
           <a:xfrm>
-            <a:off x="713232" y="5669280"/>
-            <a:ext cx="10771632" cy="566928"/>
+            <a:off x="932688" y="4553712"/>
+            <a:ext cx="10314432" cy="822960"/>
           </a:xfrm>
           <a:prstGeom prst="roundRect">
             <a:avLst/>
@@ -14879,6 +15068,121 @@
         </p:nvSpPr>
         <p:spPr>
           <a:xfrm>
+            <a:off x="1143000" y="4663440"/>
+            <a:ext cx="9893808" cy="182880"/>
+          </a:xfrm>
+          <a:prstGeom prst="rect">
+            <a:avLst/>
+          </a:prstGeom>
+          <a:noFill/>
+        </p:spPr>
+        <p:txBody>
+          <a:bodyPr wrap="square" anchor="t" lIns="18288" rIns="18288" tIns="9144" bIns="9144">
+            <a:spAutoFit/>
+          </a:bodyPr>
+          <a:lstStyle/>
+          <a:p>
+            <a:pPr algn="ctr">
+              <a:defRPr sz="900" b="1">
+                <a:solidFill>
+                  <a:srgbClr val="ACC2D6"/>
+                </a:solidFill>
+                <a:latin typeface="Malgun Gothic"/>
+              </a:defRPr>
+            </a:pPr>
+            <a:r>
+              <a:t>Xcelium 23.09  |  TB: redred_cluster2_polarity_v1_native_observational_tb.sv</a:t>
+            </a:r>
+          </a:p>
+        </p:txBody>
+      </p:sp>
+      <p:sp>
+        <p:nvSpPr>
+          <p:cNvPr id="31" name="TextBox 30"/>
+          <p:cNvSpPr txBox="1"/>
+          <p:nvPr/>
+        </p:nvSpPr>
+        <p:spPr>
+          <a:xfrm>
+            <a:off x="1143000" y="4965192"/>
+            <a:ext cx="9893808" cy="228600"/>
+          </a:xfrm>
+          <a:prstGeom prst="rect">
+            <a:avLst/>
+          </a:prstGeom>
+          <a:noFill/>
+        </p:spPr>
+        <p:txBody>
+          <a:bodyPr wrap="square" anchor="t" lIns="18288" rIns="18288" tIns="9144" bIns="9144">
+            <a:spAutoFit/>
+          </a:bodyPr>
+          <a:lstStyle/>
+          <a:p>
+            <a:pPr algn="ctr">
+              <a:defRPr sz="1200" b="1">
+                <a:solidFill>
+                  <a:srgbClr val="F6F9FC"/>
+                </a:solidFill>
+                <a:latin typeface="Malgun Gothic"/>
+              </a:defRPr>
+            </a:pPr>
+            <a:r>
+              <a:t>CYCLE 4162  |  lane0 row2 col=0x6 pol=0x0  |  lane1 row0 col=0x1 pol=0x1  →  4 events retire</a:t>
+            </a:r>
+          </a:p>
+        </p:txBody>
+      </p:sp>
+      <p:sp>
+        <p:nvSpPr>
+          <p:cNvPr id="32" name="Rounded Rectangle 31"/>
+          <p:cNvSpPr/>
+          <p:nvPr/>
+        </p:nvSpPr>
+        <p:spPr>
+          <a:xfrm>
+            <a:off x="713232" y="5669280"/>
+            <a:ext cx="10771632" cy="566928"/>
+          </a:xfrm>
+          <a:prstGeom prst="roundRect">
+            <a:avLst/>
+          </a:prstGeom>
+          <a:solidFill>
+            <a:srgbClr val="12304C"/>
+          </a:solidFill>
+          <a:ln>
+            <a:noFill/>
+          </a:ln>
+        </p:spPr>
+        <p:style>
+          <a:lnRef idx="1">
+            <a:schemeClr val="accent1"/>
+          </a:lnRef>
+          <a:fillRef idx="3">
+            <a:schemeClr val="accent1"/>
+          </a:fillRef>
+          <a:effectRef idx="2">
+            <a:schemeClr val="accent1"/>
+          </a:effectRef>
+          <a:fontRef idx="minor">
+            <a:schemeClr val="lt1"/>
+          </a:fontRef>
+        </p:style>
+        <p:txBody>
+          <a:bodyPr rtlCol="0" anchor="ctr"/>
+          <a:lstStyle/>
+          <a:p>
+            <a:pPr algn="ctr"/>
+          </a:p>
+        </p:txBody>
+      </p:sp>
+      <p:sp>
+        <p:nvSpPr>
+          <p:cNvPr id="33" name="TextBox 32"/>
+          <p:cNvSpPr txBox="1"/>
+          <p:nvPr/>
+        </p:nvSpPr>
+        <p:spPr>
+          <a:xfrm>
             <a:off x="932688" y="5806440"/>
             <a:ext cx="10332720" cy="256032"/>
           </a:xfrm>
@@ -14909,7 +15213,7 @@
       </p:sp>
       <p:sp>
         <p:nvSpPr>
-          <p:cNvPr id="31" name="Rectangle 30"/>
+          <p:cNvPr id="34" name="Rectangle 33"/>
           <p:cNvSpPr/>
           <p:nvPr/>
         </p:nvSpPr>
@@ -14952,7 +15256,7 @@
       </p:sp>
       <p:sp>
         <p:nvSpPr>
-          <p:cNvPr id="32" name="Rounded Rectangle 31"/>
+          <p:cNvPr id="35" name="Rounded Rectangle 34"/>
           <p:cNvSpPr/>
           <p:nvPr/>
         </p:nvSpPr>
@@ -14995,7 +15299,7 @@
       </p:sp>
       <p:sp>
         <p:nvSpPr>
-          <p:cNvPr id="33" name="TextBox 32"/>
+          <p:cNvPr id="36" name="TextBox 35"/>
           <p:cNvSpPr txBox="1"/>
           <p:nvPr/>
         </p:nvSpPr>
@@ -15031,7 +15335,7 @@
       </p:sp>
       <p:sp>
         <p:nvSpPr>
-          <p:cNvPr id="34" name="TextBox 33"/>
+          <p:cNvPr id="37" name="TextBox 36"/>
           <p:cNvSpPr txBox="1"/>
           <p:nvPr/>
         </p:nvSpPr>
@@ -15067,7 +15371,7 @@
       </p:sp>
       <p:sp>
         <p:nvSpPr>
-          <p:cNvPr id="35" name="Rectangle 34"/>
+          <p:cNvPr id="38" name="Rectangle 37"/>
           <p:cNvSpPr/>
           <p:nvPr/>
         </p:nvSpPr>

</xml_diff>

<commit_message>
Clarify world-frame extension terminology
</commit_message>
<xml_diff>
--- a/submission/cluster2_digital_first_round_20260828/presentation/cluster2_digital_first_round_20260828.pptx
+++ b/submission/cluster2_digital_first_round_20260828/presentation/cluster2_digital_first_round_20260828.pptx
@@ -6095,7 +6095,7 @@
               </a:defRPr>
             </a:pPr>
             <a:r>
-              <a:t>CAV 확장 경로: 8,503 events 전수 분기</a:t>
+              <a:t>World 좌표계 방향 ray 확장: 8,503 events</a:t>
             </a:r>
           </a:p>
         </p:txBody>
@@ -6169,7 +6169,7 @@
               </a:defRPr>
             </a:pPr>
             <a:r>
-              <a:t>Source: sealed legacy address-only CAV software path · separate from final polarity RTL/PPA</a:t>
+              <a:t>Source: team-defined software projection path · separate from final polarity RTL/PPA</a:t>
             </a:r>
           </a:p>
         </p:txBody>
@@ -6624,7 +6624,7 @@
               </a:defRPr>
             </a:pPr>
             <a:r>
-              <a:t>CAUSAL-CAV</a:t>
+              <a:t>WORLD-FRAME RAY</a:t>
             </a:r>
           </a:p>
         </p:txBody>
@@ -6663,7 +6663,7 @@
               </a:defRPr>
             </a:pPr>
             <a:r>
-              <a:t>occurrence-time geometry</a:t>
+              <a:t>occurrence-time pose</a:t>
             </a:r>
           </a:p>
         </p:txBody>
@@ -6963,7 +6963,7 @@
               </a:defRPr>
             </a:pPr>
             <a:r>
-              <a:t>polarity→CAV RTL/PPA는 HOLD</a:t>
+              <a:t>변환기 RTL/PPA는 HOLD</a:t>
             </a:r>
           </a:p>
         </p:txBody>
@@ -7373,7 +7373,7 @@
               </a:defRPr>
             </a:pPr>
             <a:r>
-              <a:t>확장 경로는 확인했지만 final polarity proof chain과 섞지 않았다</a:t>
+              <a:t>event + timestamp + pose의 world-frame 방향 ray 투영을 software로 확인했다</a:t>
             </a:r>
           </a:p>
         </p:txBody>
@@ -8654,7 +8654,7 @@
               </a:defRPr>
             </a:pPr>
             <a:r>
-              <a:t>CAV</a:t>
+              <a:t>WORLD</a:t>
             </a:r>
           </a:p>
         </p:txBody>
@@ -8693,7 +8693,7 @@
               </a:defRPr>
             </a:pPr>
             <a:r>
-              <a:t>source timestamp + full replay</a:t>
+              <a:t>timestamp + pose full replay</a:t>
             </a:r>
           </a:p>
         </p:txBody>

</xml_diff>

<commit_message>
Polish slide 5 and 6 layout alignment
</commit_message>
<xml_diff>
--- a/submission/cluster2_digital_first_round_20260828/presentation/cluster2_digital_first_round_20260828.pptx
+++ b/submission/cluster2_digital_first_round_20260828/presentation/cluster2_digital_first_round_20260828.pptx
@@ -14647,21 +14647,21 @@
         </p:nvSpPr>
         <p:spPr>
           <a:xfrm>
-            <a:off x="987552" y="2103120"/>
-            <a:ext cx="1005840" cy="219456"/>
-          </a:xfrm>
-          <a:prstGeom prst="rect">
-            <a:avLst/>
-          </a:prstGeom>
-          <a:noFill/>
-        </p:spPr>
-        <p:txBody>
-          <a:bodyPr wrap="square" anchor="t" lIns="27432" rIns="27432" tIns="13716" bIns="13716">
-            <a:noAutofit/>
-          </a:bodyPr>
-          <a:lstStyle/>
-          <a:p>
-            <a:pPr algn="l">
+            <a:off x="987552" y="2029968"/>
+            <a:ext cx="4645152" cy="237744"/>
+          </a:xfrm>
+          <a:prstGeom prst="rect">
+            <a:avLst/>
+          </a:prstGeom>
+          <a:noFill/>
+        </p:spPr>
+        <p:txBody>
+          <a:bodyPr wrap="square" anchor="t" lIns="27432" rIns="27432" tIns="13716" bIns="13716">
+            <a:noAutofit/>
+          </a:bodyPr>
+          <a:lstStyle/>
+          <a:p>
+            <a:pPr algn="ctr">
               <a:spcAft>
                 <a:spcPts val="0"/>
               </a:spcAft>
@@ -14673,7 +14673,7 @@
               </a:defRPr>
             </a:pPr>
             <a:r>
-              <a:t>row 2</a:t>
+              <a:t>한 row에 column 4개</a:t>
             </a:r>
           </a:p>
         </p:txBody>
@@ -14686,8 +14686,8 @@
         </p:nvSpPr>
         <p:spPr>
           <a:xfrm>
-            <a:off x="2029968" y="1984248"/>
-            <a:ext cx="512064" cy="512064"/>
+            <a:off x="1728216" y="2432304"/>
+            <a:ext cx="640080" cy="585216"/>
           </a:xfrm>
           <a:prstGeom prst="roundRect">
             <a:avLst/>
@@ -14731,8 +14731,8 @@
         </p:nvSpPr>
         <p:spPr>
           <a:xfrm>
-            <a:off x="2029968" y="2139696"/>
-            <a:ext cx="512064" cy="182880"/>
+            <a:off x="1728216" y="2542032"/>
+            <a:ext cx="640080" cy="164592"/>
           </a:xfrm>
           <a:prstGeom prst="rect">
             <a:avLst/>
@@ -14749,7 +14749,7 @@
               <a:spcAft>
                 <a:spcPts val="0"/>
               </a:spcAft>
-              <a:defRPr sz="1600" b="1">
+              <a:defRPr sz="1200" b="1">
                 <a:solidFill>
                   <a:srgbClr val="2563EB"/>
                 </a:solidFill>
@@ -14757,6 +14757,45 @@
               </a:defRPr>
             </a:pPr>
             <a:r>
+              <a:t>col0</a:t>
+            </a:r>
+          </a:p>
+        </p:txBody>
+      </p:sp>
+      <p:sp>
+        <p:nvSpPr>
+          <p:cNvPr id="14" name="TextBox 13"/>
+          <p:cNvSpPr txBox="1"/>
+          <p:nvPr/>
+        </p:nvSpPr>
+        <p:spPr>
+          <a:xfrm>
+            <a:off x="1728216" y="2761488"/>
+            <a:ext cx="640080" cy="164592"/>
+          </a:xfrm>
+          <a:prstGeom prst="rect">
+            <a:avLst/>
+          </a:prstGeom>
+          <a:noFill/>
+        </p:spPr>
+        <p:txBody>
+          <a:bodyPr wrap="square" anchor="t" lIns="27432" rIns="27432" tIns="13716" bIns="13716">
+            <a:noAutofit/>
+          </a:bodyPr>
+          <a:lstStyle/>
+          <a:p>
+            <a:pPr algn="ctr">
+              <a:spcAft>
+                <a:spcPts val="0"/>
+              </a:spcAft>
+              <a:defRPr sz="1400" b="1">
+                <a:solidFill>
+                  <a:srgbClr val="2563EB"/>
+                </a:solidFill>
+                <a:latin typeface="Malgun Gothic"/>
+              </a:defRPr>
+            </a:pPr>
+            <a:r>
               <a:t>1</a:t>
             </a:r>
           </a:p>
@@ -14764,14 +14803,14 @@
       </p:sp>
       <p:sp>
         <p:nvSpPr>
-          <p:cNvPr id="14" name="Rounded Rectangle 13"/>
+          <p:cNvPr id="15" name="Rounded Rectangle 14"/>
           <p:cNvSpPr/>
           <p:nvPr/>
         </p:nvSpPr>
         <p:spPr>
           <a:xfrm>
-            <a:off x="2724912" y="1984248"/>
-            <a:ext cx="512064" cy="512064"/>
+            <a:off x="2569464" y="2432304"/>
+            <a:ext cx="640080" cy="585216"/>
           </a:xfrm>
           <a:prstGeom prst="roundRect">
             <a:avLst/>
@@ -14809,14 +14848,14 @@
       </p:sp>
       <p:sp>
         <p:nvSpPr>
-          <p:cNvPr id="15" name="TextBox 14"/>
-          <p:cNvSpPr txBox="1"/>
-          <p:nvPr/>
-        </p:nvSpPr>
-        <p:spPr>
-          <a:xfrm>
-            <a:off x="2724912" y="2139696"/>
-            <a:ext cx="512064" cy="182880"/>
+          <p:cNvPr id="16" name="TextBox 15"/>
+          <p:cNvSpPr txBox="1"/>
+          <p:nvPr/>
+        </p:nvSpPr>
+        <p:spPr>
+          <a:xfrm>
+            <a:off x="2569464" y="2542032"/>
+            <a:ext cx="640080" cy="164592"/>
           </a:xfrm>
           <a:prstGeom prst="rect">
             <a:avLst/>
@@ -14833,7 +14872,7 @@
               <a:spcAft>
                 <a:spcPts val="0"/>
               </a:spcAft>
-              <a:defRPr sz="1600" b="1">
+              <a:defRPr sz="1200" b="1">
                 <a:solidFill>
                   <a:srgbClr val="2563EB"/>
                 </a:solidFill>
@@ -14841,6 +14880,45 @@
               </a:defRPr>
             </a:pPr>
             <a:r>
+              <a:t>col1</a:t>
+            </a:r>
+          </a:p>
+        </p:txBody>
+      </p:sp>
+      <p:sp>
+        <p:nvSpPr>
+          <p:cNvPr id="17" name="TextBox 16"/>
+          <p:cNvSpPr txBox="1"/>
+          <p:nvPr/>
+        </p:nvSpPr>
+        <p:spPr>
+          <a:xfrm>
+            <a:off x="2569464" y="2761488"/>
+            <a:ext cx="640080" cy="164592"/>
+          </a:xfrm>
+          <a:prstGeom prst="rect">
+            <a:avLst/>
+          </a:prstGeom>
+          <a:noFill/>
+        </p:spPr>
+        <p:txBody>
+          <a:bodyPr wrap="square" anchor="t" lIns="27432" rIns="27432" tIns="13716" bIns="13716">
+            <a:noAutofit/>
+          </a:bodyPr>
+          <a:lstStyle/>
+          <a:p>
+            <a:pPr algn="ctr">
+              <a:spcAft>
+                <a:spcPts val="0"/>
+              </a:spcAft>
+              <a:defRPr sz="1400" b="1">
+                <a:solidFill>
+                  <a:srgbClr val="2563EB"/>
+                </a:solidFill>
+                <a:latin typeface="Malgun Gothic"/>
+              </a:defRPr>
+            </a:pPr>
+            <a:r>
               <a:t>1</a:t>
             </a:r>
           </a:p>
@@ -14848,14 +14926,14 @@
       </p:sp>
       <p:sp>
         <p:nvSpPr>
-          <p:cNvPr id="16" name="Rounded Rectangle 15"/>
+          <p:cNvPr id="18" name="Rounded Rectangle 17"/>
           <p:cNvSpPr/>
           <p:nvPr/>
         </p:nvSpPr>
         <p:spPr>
           <a:xfrm>
-            <a:off x="3419856" y="1984248"/>
-            <a:ext cx="512064" cy="512064"/>
+            <a:off x="3410712" y="2432304"/>
+            <a:ext cx="640080" cy="585216"/>
           </a:xfrm>
           <a:prstGeom prst="roundRect">
             <a:avLst/>
@@ -14893,14 +14971,14 @@
       </p:sp>
       <p:sp>
         <p:nvSpPr>
-          <p:cNvPr id="17" name="TextBox 16"/>
-          <p:cNvSpPr txBox="1"/>
-          <p:nvPr/>
-        </p:nvSpPr>
-        <p:spPr>
-          <a:xfrm>
-            <a:off x="3419856" y="2139696"/>
-            <a:ext cx="512064" cy="182880"/>
+          <p:cNvPr id="19" name="TextBox 18"/>
+          <p:cNvSpPr txBox="1"/>
+          <p:nvPr/>
+        </p:nvSpPr>
+        <p:spPr>
+          <a:xfrm>
+            <a:off x="3410712" y="2542032"/>
+            <a:ext cx="640080" cy="164592"/>
           </a:xfrm>
           <a:prstGeom prst="rect">
             <a:avLst/>
@@ -14917,7 +14995,7 @@
               <a:spcAft>
                 <a:spcPts val="0"/>
               </a:spcAft>
-              <a:defRPr sz="1600" b="1">
+              <a:defRPr sz="1200" b="1">
                 <a:solidFill>
                   <a:srgbClr val="2563EB"/>
                 </a:solidFill>
@@ -14925,6 +15003,45 @@
               </a:defRPr>
             </a:pPr>
             <a:r>
+              <a:t>col2</a:t>
+            </a:r>
+          </a:p>
+        </p:txBody>
+      </p:sp>
+      <p:sp>
+        <p:nvSpPr>
+          <p:cNvPr id="20" name="TextBox 19"/>
+          <p:cNvSpPr txBox="1"/>
+          <p:nvPr/>
+        </p:nvSpPr>
+        <p:spPr>
+          <a:xfrm>
+            <a:off x="3410712" y="2761488"/>
+            <a:ext cx="640080" cy="164592"/>
+          </a:xfrm>
+          <a:prstGeom prst="rect">
+            <a:avLst/>
+          </a:prstGeom>
+          <a:noFill/>
+        </p:spPr>
+        <p:txBody>
+          <a:bodyPr wrap="square" anchor="t" lIns="27432" rIns="27432" tIns="13716" bIns="13716">
+            <a:noAutofit/>
+          </a:bodyPr>
+          <a:lstStyle/>
+          <a:p>
+            <a:pPr algn="ctr">
+              <a:spcAft>
+                <a:spcPts val="0"/>
+              </a:spcAft>
+              <a:defRPr sz="1400" b="1">
+                <a:solidFill>
+                  <a:srgbClr val="2563EB"/>
+                </a:solidFill>
+                <a:latin typeface="Malgun Gothic"/>
+              </a:defRPr>
+            </a:pPr>
+            <a:r>
               <a:t>1</a:t>
             </a:r>
           </a:p>
@@ -14932,14 +15049,14 @@
       </p:sp>
       <p:sp>
         <p:nvSpPr>
-          <p:cNvPr id="18" name="Rounded Rectangle 17"/>
+          <p:cNvPr id="21" name="Rounded Rectangle 20"/>
           <p:cNvSpPr/>
           <p:nvPr/>
         </p:nvSpPr>
         <p:spPr>
           <a:xfrm>
-            <a:off x="4114800" y="1984248"/>
-            <a:ext cx="512064" cy="512064"/>
+            <a:off x="4251960" y="2432304"/>
+            <a:ext cx="640080" cy="585216"/>
           </a:xfrm>
           <a:prstGeom prst="roundRect">
             <a:avLst/>
@@ -14977,14 +15094,14 @@
       </p:sp>
       <p:sp>
         <p:nvSpPr>
-          <p:cNvPr id="19" name="TextBox 18"/>
-          <p:cNvSpPr txBox="1"/>
-          <p:nvPr/>
-        </p:nvSpPr>
-        <p:spPr>
-          <a:xfrm>
-            <a:off x="4114800" y="2139696"/>
-            <a:ext cx="512064" cy="182880"/>
+          <p:cNvPr id="22" name="TextBox 21"/>
+          <p:cNvSpPr txBox="1"/>
+          <p:nvPr/>
+        </p:nvSpPr>
+        <p:spPr>
+          <a:xfrm>
+            <a:off x="4251960" y="2542032"/>
+            <a:ext cx="640080" cy="164592"/>
           </a:xfrm>
           <a:prstGeom prst="rect">
             <a:avLst/>
@@ -15001,7 +15118,7 @@
               <a:spcAft>
                 <a:spcPts val="0"/>
               </a:spcAft>
-              <a:defRPr sz="1600" b="1">
+              <a:defRPr sz="1200" b="1">
                 <a:solidFill>
                   <a:srgbClr val="2563EB"/>
                 </a:solidFill>
@@ -15009,6 +15126,45 @@
               </a:defRPr>
             </a:pPr>
             <a:r>
+              <a:t>col3</a:t>
+            </a:r>
+          </a:p>
+        </p:txBody>
+      </p:sp>
+      <p:sp>
+        <p:nvSpPr>
+          <p:cNvPr id="23" name="TextBox 22"/>
+          <p:cNvSpPr txBox="1"/>
+          <p:nvPr/>
+        </p:nvSpPr>
+        <p:spPr>
+          <a:xfrm>
+            <a:off x="4251960" y="2761488"/>
+            <a:ext cx="640080" cy="164592"/>
+          </a:xfrm>
+          <a:prstGeom prst="rect">
+            <a:avLst/>
+          </a:prstGeom>
+          <a:noFill/>
+        </p:spPr>
+        <p:txBody>
+          <a:bodyPr wrap="square" anchor="t" lIns="27432" rIns="27432" tIns="13716" bIns="13716">
+            <a:noAutofit/>
+          </a:bodyPr>
+          <a:lstStyle/>
+          <a:p>
+            <a:pPr algn="ctr">
+              <a:spcAft>
+                <a:spcPts val="0"/>
+              </a:spcAft>
+              <a:defRPr sz="1400" b="1">
+                <a:solidFill>
+                  <a:srgbClr val="2563EB"/>
+                </a:solidFill>
+                <a:latin typeface="Malgun Gothic"/>
+              </a:defRPr>
+            </a:pPr>
+            <a:r>
               <a:t>1</a:t>
             </a:r>
           </a:p>
@@ -15016,55 +15172,16 @@
       </p:sp>
       <p:sp>
         <p:nvSpPr>
-          <p:cNvPr id="20" name="TextBox 19"/>
-          <p:cNvSpPr txBox="1"/>
-          <p:nvPr/>
-        </p:nvSpPr>
-        <p:spPr>
-          <a:xfrm>
-            <a:off x="987552" y="2926080"/>
-            <a:ext cx="1481328" cy="256032"/>
-          </a:xfrm>
-          <a:prstGeom prst="rect">
-            <a:avLst/>
-          </a:prstGeom>
-          <a:noFill/>
-        </p:spPr>
-        <p:txBody>
-          <a:bodyPr wrap="square" anchor="t" lIns="27432" rIns="27432" tIns="13716" bIns="13716">
-            <a:noAutofit/>
-          </a:bodyPr>
-          <a:lstStyle/>
-          <a:p>
-            <a:pPr algn="l">
-              <a:spcAft>
-                <a:spcPts val="0"/>
-              </a:spcAft>
-              <a:defRPr sz="1600" b="1">
-                <a:solidFill>
-                  <a:srgbClr val="0F2234"/>
-                </a:solidFill>
-                <a:latin typeface="Malgun Gothic"/>
-              </a:defRPr>
-            </a:pPr>
-            <a:r>
-              <a:t>네 scalar 주소</a:t>
-            </a:r>
-          </a:p>
-        </p:txBody>
-      </p:sp>
-      <p:sp>
-        <p:nvSpPr>
-          <p:cNvPr id="21" name="Right Arrow 20"/>
+          <p:cNvPr id="24" name="Down Arrow 23"/>
           <p:cNvSpPr/>
           <p:nvPr/>
         </p:nvSpPr>
         <p:spPr>
           <a:xfrm>
-            <a:off x="2651760" y="2926080"/>
-            <a:ext cx="475488" cy="256032"/>
-          </a:xfrm>
-          <a:prstGeom prst="rightArrow">
+            <a:off x="3182112" y="3072384"/>
+            <a:ext cx="256032" cy="237744"/>
+          </a:xfrm>
+          <a:prstGeom prst="downArrow">
             <a:avLst/>
           </a:prstGeom>
           <a:solidFill>
@@ -15098,14 +15215,14 @@
       </p:sp>
       <p:sp>
         <p:nvSpPr>
-          <p:cNvPr id="22" name="Rounded Rectangle 21"/>
+          <p:cNvPr id="25" name="Rounded Rectangle 24"/>
           <p:cNvSpPr/>
           <p:nvPr/>
         </p:nvSpPr>
         <p:spPr>
           <a:xfrm>
-            <a:off x="3383280" y="2770632"/>
-            <a:ext cx="1993392" cy="640080"/>
+            <a:off x="1335024" y="3401568"/>
+            <a:ext cx="3950208" cy="676656"/>
           </a:xfrm>
           <a:prstGeom prst="roundRect">
             <a:avLst/>
@@ -15141,14 +15258,14 @@
       </p:sp>
       <p:sp>
         <p:nvSpPr>
-          <p:cNvPr id="23" name="TextBox 22"/>
-          <p:cNvSpPr txBox="1"/>
-          <p:nvPr/>
-        </p:nvSpPr>
-        <p:spPr>
-          <a:xfrm>
-            <a:off x="3566160" y="2980944"/>
-            <a:ext cx="1627632" cy="219456"/>
+          <p:cNvPr id="26" name="TextBox 25"/>
+          <p:cNvSpPr txBox="1"/>
+          <p:nvPr/>
+        </p:nvSpPr>
+        <p:spPr>
+          <a:xfrm>
+            <a:off x="1554480" y="3611880"/>
+            <a:ext cx="3511296" cy="219456"/>
           </a:xfrm>
           <a:prstGeom prst="rect">
             <a:avLst/>
@@ -15173,53 +15290,96 @@
               </a:defRPr>
             </a:pPr>
             <a:r>
-              <a:t>row + 1111</a:t>
-            </a:r>
-          </a:p>
-        </p:txBody>
-      </p:sp>
-      <p:sp>
-        <p:nvSpPr>
-          <p:cNvPr id="24" name="TextBox 23"/>
-          <p:cNvSpPr txBox="1"/>
-          <p:nvPr/>
-        </p:nvSpPr>
-        <p:spPr>
-          <a:xfrm>
-            <a:off x="987552" y="3931920"/>
-            <a:ext cx="4526280" cy="274320"/>
-          </a:xfrm>
-          <a:prstGeom prst="rect">
-            <a:avLst/>
-          </a:prstGeom>
-          <a:noFill/>
-        </p:spPr>
-        <p:txBody>
-          <a:bodyPr wrap="square" anchor="t" lIns="27432" rIns="27432" tIns="13716" bIns="13716">
-            <a:noAutofit/>
-          </a:bodyPr>
-          <a:lstStyle/>
-          <a:p>
-            <a:pPr algn="l">
-              <a:spcAft>
-                <a:spcPts val="0"/>
-              </a:spcAft>
-              <a:defRPr sz="1600" b="0">
-                <a:solidFill>
-                  <a:srgbClr val="4C6073"/>
-                </a:solidFill>
-                <a:latin typeface="Malgun Gothic"/>
-              </a:defRPr>
-            </a:pPr>
-            <a:r>
-              <a:t>한 lane transaction = 최대 4 events</a:t>
-            </a:r>
-          </a:p>
-        </p:txBody>
-      </p:sp>
-      <p:sp>
-        <p:nvSpPr>
-          <p:cNvPr id="25" name="Rounded Rectangle 24"/>
+              <a:t>row 2  +  col_mask 1111</a:t>
+            </a:r>
+          </a:p>
+        </p:txBody>
+      </p:sp>
+      <p:sp>
+        <p:nvSpPr>
+          <p:cNvPr id="27" name="Rounded Rectangle 26"/>
+          <p:cNvSpPr/>
+          <p:nvPr/>
+        </p:nvSpPr>
+        <p:spPr>
+          <a:xfrm>
+            <a:off x="1170432" y="4407408"/>
+            <a:ext cx="4279392" cy="493776"/>
+          </a:xfrm>
+          <a:prstGeom prst="roundRect">
+            <a:avLst/>
+          </a:prstGeom>
+          <a:solidFill>
+            <a:srgbClr val="EBF1F6"/>
+          </a:solidFill>
+          <a:ln>
+            <a:noFill/>
+          </a:ln>
+        </p:spPr>
+        <p:style>
+          <a:lnRef idx="1">
+            <a:schemeClr val="accent1"/>
+          </a:lnRef>
+          <a:fillRef idx="3">
+            <a:schemeClr val="accent1"/>
+          </a:fillRef>
+          <a:effectRef idx="2">
+            <a:schemeClr val="accent1"/>
+          </a:effectRef>
+          <a:fontRef idx="minor">
+            <a:schemeClr val="lt1"/>
+          </a:fontRef>
+        </p:style>
+        <p:txBody>
+          <a:bodyPr rtlCol="0" anchor="ctr"/>
+          <a:lstStyle/>
+          <a:p>
+            <a:pPr algn="ctr"/>
+          </a:p>
+        </p:txBody>
+      </p:sp>
+      <p:sp>
+        <p:nvSpPr>
+          <p:cNvPr id="28" name="TextBox 27"/>
+          <p:cNvSpPr txBox="1"/>
+          <p:nvPr/>
+        </p:nvSpPr>
+        <p:spPr>
+          <a:xfrm>
+            <a:off x="1389888" y="4553712"/>
+            <a:ext cx="3840480" cy="201168"/>
+          </a:xfrm>
+          <a:prstGeom prst="rect">
+            <a:avLst/>
+          </a:prstGeom>
+          <a:noFill/>
+        </p:spPr>
+        <p:txBody>
+          <a:bodyPr wrap="square" anchor="t" lIns="27432" rIns="27432" tIns="13716" bIns="13716">
+            <a:noAutofit/>
+          </a:bodyPr>
+          <a:lstStyle/>
+          <a:p>
+            <a:pPr algn="ctr">
+              <a:spcAft>
+                <a:spcPts val="0"/>
+              </a:spcAft>
+              <a:defRPr sz="1400" b="1">
+                <a:solidFill>
+                  <a:srgbClr val="13344F"/>
+                </a:solidFill>
+                <a:latin typeface="Malgun Gothic"/>
+              </a:defRPr>
+            </a:pPr>
+            <a:r>
+              <a:t>lane transaction 1회 · event 최대 4개</a:t>
+            </a:r>
+          </a:p>
+        </p:txBody>
+      </p:sp>
+      <p:sp>
+        <p:nvSpPr>
+          <p:cNvPr id="29" name="Rounded Rectangle 28"/>
           <p:cNvSpPr/>
           <p:nvPr/>
         </p:nvSpPr>
@@ -15264,7 +15424,7 @@
       </p:sp>
       <p:sp>
         <p:nvSpPr>
-          <p:cNvPr id="26" name="TextBox 25"/>
+          <p:cNvPr id="30" name="TextBox 29"/>
           <p:cNvSpPr txBox="1"/>
           <p:nvPr/>
         </p:nvSpPr>
@@ -15303,7 +15463,7 @@
       </p:sp>
       <p:sp>
         <p:nvSpPr>
-          <p:cNvPr id="27" name="TextBox 26"/>
+          <p:cNvPr id="31" name="TextBox 30"/>
           <p:cNvSpPr txBox="1"/>
           <p:nvPr/>
         </p:nvSpPr>
@@ -15342,27 +15502,27 @@
       </p:sp>
       <p:sp>
         <p:nvSpPr>
-          <p:cNvPr id="28" name="TextBox 27"/>
-          <p:cNvSpPr txBox="1"/>
-          <p:nvPr/>
-        </p:nvSpPr>
-        <p:spPr>
-          <a:xfrm>
-            <a:off x="6565392" y="2103120"/>
-            <a:ext cx="1298448" cy="219456"/>
-          </a:xfrm>
-          <a:prstGeom prst="rect">
-            <a:avLst/>
-          </a:prstGeom>
-          <a:noFill/>
-        </p:spPr>
-        <p:txBody>
-          <a:bodyPr wrap="square" anchor="t" lIns="27432" rIns="27432" tIns="13716" bIns="13716">
-            <a:noAutofit/>
-          </a:bodyPr>
-          <a:lstStyle/>
-          <a:p>
-            <a:pPr algn="l">
+          <p:cNvPr id="32" name="TextBox 31"/>
+          <p:cNvSpPr txBox="1"/>
+          <p:nvPr/>
+        </p:nvSpPr>
+        <p:spPr>
+          <a:xfrm>
+            <a:off x="6565392" y="2029968"/>
+            <a:ext cx="4645152" cy="237744"/>
+          </a:xfrm>
+          <a:prstGeom prst="rect">
+            <a:avLst/>
+          </a:prstGeom>
+          <a:noFill/>
+        </p:spPr>
+        <p:txBody>
+          <a:bodyPr wrap="square" anchor="t" lIns="27432" rIns="27432" tIns="13716" bIns="13716">
+            <a:noAutofit/>
+          </a:bodyPr>
+          <a:lstStyle/>
+          <a:p>
+            <a:pPr algn="ctr">
               <a:spcAft>
                 <a:spcPts val="0"/>
               </a:spcAft>
@@ -15374,21 +15534,21 @@
               </a:defRPr>
             </a:pPr>
             <a:r>
-              <a:t>같은 source</a:t>
-            </a:r>
-          </a:p>
-        </p:txBody>
-      </p:sp>
-      <p:sp>
-        <p:nvSpPr>
-          <p:cNvPr id="29" name="Rounded Rectangle 28"/>
+              <a:t>같은 source에서 연속 발생</a:t>
+            </a:r>
+          </a:p>
+        </p:txBody>
+      </p:sp>
+      <p:sp>
+        <p:nvSpPr>
+          <p:cNvPr id="33" name="Rounded Rectangle 32"/>
           <p:cNvSpPr/>
           <p:nvPr/>
         </p:nvSpPr>
         <p:spPr>
           <a:xfrm>
-            <a:off x="8065008" y="1901952"/>
-            <a:ext cx="1188720" cy="749808"/>
+            <a:off x="6839712" y="2432304"/>
+            <a:ext cx="1865376" cy="841248"/>
           </a:xfrm>
           <a:prstGeom prst="roundRect">
             <a:avLst/>
@@ -15426,14 +15586,14 @@
       </p:sp>
       <p:sp>
         <p:nvSpPr>
-          <p:cNvPr id="30" name="TextBox 29"/>
-          <p:cNvSpPr txBox="1"/>
-          <p:nvPr/>
-        </p:nvSpPr>
-        <p:spPr>
-          <a:xfrm>
-            <a:off x="8065008" y="2057400"/>
-            <a:ext cx="1188720" cy="402336"/>
+          <p:cNvPr id="34" name="TextBox 33"/>
+          <p:cNvSpPr txBox="1"/>
+          <p:nvPr/>
+        </p:nvSpPr>
+        <p:spPr>
+          <a:xfrm>
+            <a:off x="6839712" y="2578608"/>
+            <a:ext cx="1865376" cy="182880"/>
           </a:xfrm>
           <a:prstGeom prst="rect">
             <a:avLst/>
@@ -15450,33 +15610,68 @@
               <a:spcAft>
                 <a:spcPts val="0"/>
               </a:spcAft>
+              <a:defRPr sz="1200" b="1">
+                <a:solidFill>
+                  <a:srgbClr val="E68414"/>
+                </a:solidFill>
+                <a:latin typeface="Malgun Gothic"/>
+              </a:defRPr>
+            </a:pPr>
+            <a:r>
+              <a:t>SLOT 0</a:t>
+            </a:r>
+          </a:p>
+        </p:txBody>
+      </p:sp>
+      <p:sp>
+        <p:nvSpPr>
+          <p:cNvPr id="35" name="TextBox 34"/>
+          <p:cNvSpPr txBox="1"/>
+          <p:nvPr/>
+        </p:nvSpPr>
+        <p:spPr>
+          <a:xfrm>
+            <a:off x="6839712" y="2871216"/>
+            <a:ext cx="1865376" cy="201168"/>
+          </a:xfrm>
+          <a:prstGeom prst="rect">
+            <a:avLst/>
+          </a:prstGeom>
+          <a:noFill/>
+        </p:spPr>
+        <p:txBody>
+          <a:bodyPr wrap="square" anchor="t" lIns="27432" rIns="27432" tIns="13716" bIns="13716">
+            <a:noAutofit/>
+          </a:bodyPr>
+          <a:lstStyle/>
+          <a:p>
+            <a:pPr algn="ctr">
+              <a:spcAft>
+                <a:spcPts val="0"/>
+              </a:spcAft>
               <a:defRPr sz="1500" b="1">
                 <a:solidFill>
-                  <a:srgbClr val="E68414"/>
-                </a:solidFill>
-                <a:latin typeface="Malgun Gothic"/>
-              </a:defRPr>
-            </a:pPr>
-            <a:r>
-              <a:t>slot 0</a:t>
-            </a:r>
-            <a:br/>
-            <a:r>
-              <a:t>A</a:t>
-            </a:r>
-          </a:p>
-        </p:txBody>
-      </p:sp>
-      <p:sp>
-        <p:nvSpPr>
-          <p:cNvPr id="31" name="Rounded Rectangle 30"/>
+                  <a:srgbClr val="0F2234"/>
+                </a:solidFill>
+                <a:latin typeface="Malgun Gothic"/>
+              </a:defRPr>
+            </a:pPr>
+            <a:r>
+              <a:t>A · 대기</a:t>
+            </a:r>
+          </a:p>
+        </p:txBody>
+      </p:sp>
+      <p:sp>
+        <p:nvSpPr>
+          <p:cNvPr id="36" name="Rounded Rectangle 35"/>
           <p:cNvSpPr/>
           <p:nvPr/>
         </p:nvSpPr>
         <p:spPr>
           <a:xfrm>
-            <a:off x="9454896" y="1901952"/>
-            <a:ext cx="1188720" cy="749808"/>
+            <a:off x="9070848" y="2432304"/>
+            <a:ext cx="1865376" cy="841248"/>
           </a:xfrm>
           <a:prstGeom prst="roundRect">
             <a:avLst/>
@@ -15514,14 +15709,14 @@
       </p:sp>
       <p:sp>
         <p:nvSpPr>
-          <p:cNvPr id="32" name="TextBox 31"/>
-          <p:cNvSpPr txBox="1"/>
-          <p:nvPr/>
-        </p:nvSpPr>
-        <p:spPr>
-          <a:xfrm>
-            <a:off x="9454896" y="2057400"/>
-            <a:ext cx="1188720" cy="402336"/>
+          <p:cNvPr id="37" name="TextBox 36"/>
+          <p:cNvSpPr txBox="1"/>
+          <p:nvPr/>
+        </p:nvSpPr>
+        <p:spPr>
+          <a:xfrm>
+            <a:off x="9070848" y="2578608"/>
+            <a:ext cx="1865376" cy="182880"/>
           </a:xfrm>
           <a:prstGeom prst="rect">
             <a:avLst/>
@@ -15538,111 +15733,236 @@
               <a:spcAft>
                 <a:spcPts val="0"/>
               </a:spcAft>
+              <a:defRPr sz="1200" b="1">
+                <a:solidFill>
+                  <a:srgbClr val="E68414"/>
+                </a:solidFill>
+                <a:latin typeface="Malgun Gothic"/>
+              </a:defRPr>
+            </a:pPr>
+            <a:r>
+              <a:t>SLOT 1</a:t>
+            </a:r>
+          </a:p>
+        </p:txBody>
+      </p:sp>
+      <p:sp>
+        <p:nvSpPr>
+          <p:cNvPr id="38" name="TextBox 37"/>
+          <p:cNvSpPr txBox="1"/>
+          <p:nvPr/>
+        </p:nvSpPr>
+        <p:spPr>
+          <a:xfrm>
+            <a:off x="9070848" y="2871216"/>
+            <a:ext cx="1865376" cy="201168"/>
+          </a:xfrm>
+          <a:prstGeom prst="rect">
+            <a:avLst/>
+          </a:prstGeom>
+          <a:noFill/>
+        </p:spPr>
+        <p:txBody>
+          <a:bodyPr wrap="square" anchor="t" lIns="27432" rIns="27432" tIns="13716" bIns="13716">
+            <a:noAutofit/>
+          </a:bodyPr>
+          <a:lstStyle/>
+          <a:p>
+            <a:pPr algn="ctr">
+              <a:spcAft>
+                <a:spcPts val="0"/>
+              </a:spcAft>
               <a:defRPr sz="1500" b="1">
                 <a:solidFill>
+                  <a:srgbClr val="0F2234"/>
+                </a:solidFill>
+                <a:latin typeface="Malgun Gothic"/>
+              </a:defRPr>
+            </a:pPr>
+            <a:r>
+              <a:t>B · 재발생</a:t>
+            </a:r>
+          </a:p>
+        </p:txBody>
+      </p:sp>
+      <p:sp>
+        <p:nvSpPr>
+          <p:cNvPr id="39" name="Right Arrow 38"/>
+          <p:cNvSpPr/>
+          <p:nvPr/>
+        </p:nvSpPr>
+        <p:spPr>
+          <a:xfrm>
+            <a:off x="8778240" y="2724912"/>
+            <a:ext cx="219456" cy="201168"/>
+          </a:xfrm>
+          <a:prstGeom prst="rightArrow">
+            <a:avLst/>
+          </a:prstGeom>
+          <a:solidFill>
+            <a:srgbClr val="E68414"/>
+          </a:solidFill>
+          <a:ln>
+            <a:noFill/>
+          </a:ln>
+        </p:spPr>
+        <p:style>
+          <a:lnRef idx="1">
+            <a:schemeClr val="accent1"/>
+          </a:lnRef>
+          <a:fillRef idx="3">
+            <a:schemeClr val="accent1"/>
+          </a:fillRef>
+          <a:effectRef idx="2">
+            <a:schemeClr val="accent1"/>
+          </a:effectRef>
+          <a:fontRef idx="minor">
+            <a:schemeClr val="lt1"/>
+          </a:fontRef>
+        </p:style>
+        <p:txBody>
+          <a:bodyPr rtlCol="0" anchor="ctr"/>
+          <a:lstStyle/>
+          <a:p>
+            <a:pPr algn="ctr"/>
+          </a:p>
+        </p:txBody>
+      </p:sp>
+      <p:sp>
+        <p:nvSpPr>
+          <p:cNvPr id="40" name="Down Arrow 39"/>
+          <p:cNvSpPr/>
+          <p:nvPr/>
+        </p:nvSpPr>
+        <p:spPr>
+          <a:xfrm>
+            <a:off x="8759952" y="3328416"/>
+            <a:ext cx="256032" cy="219456"/>
+          </a:xfrm>
+          <a:prstGeom prst="downArrow">
+            <a:avLst/>
+          </a:prstGeom>
+          <a:solidFill>
+            <a:srgbClr val="E68414"/>
+          </a:solidFill>
+          <a:ln>
+            <a:noFill/>
+          </a:ln>
+        </p:spPr>
+        <p:style>
+          <a:lnRef idx="1">
+            <a:schemeClr val="accent1"/>
+          </a:lnRef>
+          <a:fillRef idx="3">
+            <a:schemeClr val="accent1"/>
+          </a:fillRef>
+          <a:effectRef idx="2">
+            <a:schemeClr val="accent1"/>
+          </a:effectRef>
+          <a:fontRef idx="minor">
+            <a:schemeClr val="lt1"/>
+          </a:fontRef>
+        </p:style>
+        <p:txBody>
+          <a:bodyPr rtlCol="0" anchor="ctr"/>
+          <a:lstStyle/>
+          <a:p>
+            <a:pPr algn="ctr"/>
+          </a:p>
+        </p:txBody>
+      </p:sp>
+      <p:sp>
+        <p:nvSpPr>
+          <p:cNvPr id="41" name="Rounded Rectangle 40"/>
+          <p:cNvSpPr/>
+          <p:nvPr/>
+        </p:nvSpPr>
+        <p:spPr>
+          <a:xfrm>
+            <a:off x="6821424" y="3621024"/>
+            <a:ext cx="4133087" cy="621792"/>
+          </a:xfrm>
+          <a:prstGeom prst="roundRect">
+            <a:avLst/>
+          </a:prstGeom>
+          <a:solidFill>
+            <a:srgbClr val="FFF2DC"/>
+          </a:solidFill>
+          <a:ln>
+            <a:noFill/>
+          </a:ln>
+        </p:spPr>
+        <p:style>
+          <a:lnRef idx="1">
+            <a:schemeClr val="accent1"/>
+          </a:lnRef>
+          <a:fillRef idx="3">
+            <a:schemeClr val="accent1"/>
+          </a:fillRef>
+          <a:effectRef idx="2">
+            <a:schemeClr val="accent1"/>
+          </a:effectRef>
+          <a:fontRef idx="minor">
+            <a:schemeClr val="lt1"/>
+          </a:fontRef>
+        </p:style>
+        <p:txBody>
+          <a:bodyPr rtlCol="0" anchor="ctr"/>
+          <a:lstStyle/>
+          <a:p>
+            <a:pPr algn="ctr"/>
+          </a:p>
+        </p:txBody>
+      </p:sp>
+      <p:sp>
+        <p:nvSpPr>
+          <p:cNvPr id="42" name="TextBox 41"/>
+          <p:cNvSpPr txBox="1"/>
+          <p:nvPr/>
+        </p:nvSpPr>
+        <p:spPr>
+          <a:xfrm>
+            <a:off x="7040880" y="3822191"/>
+            <a:ext cx="3694176" cy="219456"/>
+          </a:xfrm>
+          <a:prstGeom prst="rect">
+            <a:avLst/>
+          </a:prstGeom>
+          <a:noFill/>
+        </p:spPr>
+        <p:txBody>
+          <a:bodyPr wrap="square" anchor="t" lIns="27432" rIns="27432" tIns="13716" bIns="13716">
+            <a:noAutofit/>
+          </a:bodyPr>
+          <a:lstStyle/>
+          <a:p>
+            <a:pPr algn="ctr">
+              <a:spcAft>
+                <a:spcPts val="0"/>
+              </a:spcAft>
+              <a:defRPr sz="1700" b="1">
+                <a:solidFill>
                   <a:srgbClr val="E68414"/>
                 </a:solidFill>
                 <a:latin typeface="Malgun Gothic"/>
               </a:defRPr>
             </a:pPr>
             <a:r>
-              <a:t>slot 1</a:t>
-            </a:r>
-            <a:br/>
-            <a:r>
-              <a:t>B</a:t>
-            </a:r>
-          </a:p>
-        </p:txBody>
-      </p:sp>
-      <p:sp>
-        <p:nvSpPr>
-          <p:cNvPr id="33" name="TextBox 32"/>
-          <p:cNvSpPr txBox="1"/>
-          <p:nvPr/>
-        </p:nvSpPr>
-        <p:spPr>
-          <a:xfrm>
-            <a:off x="6565392" y="3063240"/>
-            <a:ext cx="4526280" cy="274320"/>
-          </a:xfrm>
-          <a:prstGeom prst="rect">
-            <a:avLst/>
-          </a:prstGeom>
-          <a:noFill/>
-        </p:spPr>
-        <p:txBody>
-          <a:bodyPr wrap="square" anchor="t" lIns="27432" rIns="27432" tIns="13716" bIns="13716">
-            <a:noAutofit/>
-          </a:bodyPr>
-          <a:lstStyle/>
-          <a:p>
-            <a:pPr algn="l">
-              <a:spcAft>
-                <a:spcPts val="0"/>
-              </a:spcAft>
-              <a:defRPr sz="1600" b="1">
-                <a:solidFill>
-                  <a:srgbClr val="0F2234"/>
-                </a:solidFill>
-                <a:latin typeface="Malgun Gothic"/>
-              </a:defRPr>
-            </a:pPr>
-            <a:r>
-              <a:t>A가 grant를 기다리는 동안 B 재발생</a:t>
-            </a:r>
-          </a:p>
-        </p:txBody>
-      </p:sp>
-      <p:sp>
-        <p:nvSpPr>
-          <p:cNvPr id="34" name="TextBox 33"/>
-          <p:cNvSpPr txBox="1"/>
-          <p:nvPr/>
-        </p:nvSpPr>
-        <p:spPr>
-          <a:xfrm>
-            <a:off x="6565392" y="3913632"/>
-            <a:ext cx="4526280" cy="274320"/>
-          </a:xfrm>
-          <a:prstGeom prst="rect">
-            <a:avLst/>
-          </a:prstGeom>
-          <a:noFill/>
-        </p:spPr>
-        <p:txBody>
-          <a:bodyPr wrap="square" anchor="t" lIns="27432" rIns="27432" tIns="13716" bIns="13716">
-            <a:noAutofit/>
-          </a:bodyPr>
-          <a:lstStyle/>
-          <a:p>
-            <a:pPr algn="l">
-              <a:spcAft>
-                <a:spcPts val="0"/>
-              </a:spcAft>
-              <a:defRPr sz="1600" b="0">
-                <a:solidFill>
-                  <a:srgbClr val="4C6073"/>
-                </a:solidFill>
-                <a:latin typeface="Malgun Gothic"/>
-              </a:defRPr>
-            </a:pPr>
-            <a:r>
-              <a:t>두 번째 occurrence를 overrun 대신 저장</a:t>
-            </a:r>
-          </a:p>
-        </p:txBody>
-      </p:sp>
-      <p:sp>
-        <p:nvSpPr>
-          <p:cNvPr id="35" name="Rounded Rectangle 34"/>
+              <a:t>B를 slot 1에 저장</a:t>
+            </a:r>
+          </a:p>
+        </p:txBody>
+      </p:sp>
+      <p:sp>
+        <p:nvSpPr>
+          <p:cNvPr id="43" name="Rounded Rectangle 42"/>
           <p:cNvSpPr/>
           <p:nvPr/>
         </p:nvSpPr>
         <p:spPr>
           <a:xfrm>
-            <a:off x="658368" y="5742432"/>
-            <a:ext cx="10881360" cy="566928"/>
+            <a:off x="6656832" y="4407408"/>
+            <a:ext cx="4462272" cy="493776"/>
           </a:xfrm>
           <a:prstGeom prst="roundRect">
             <a:avLst/>
@@ -15678,7 +15998,89 @@
       </p:sp>
       <p:sp>
         <p:nvSpPr>
-          <p:cNvPr id="36" name="Rectangle 35"/>
+          <p:cNvPr id="44" name="TextBox 43"/>
+          <p:cNvSpPr txBox="1"/>
+          <p:nvPr/>
+        </p:nvSpPr>
+        <p:spPr>
+          <a:xfrm>
+            <a:off x="6876288" y="4553712"/>
+            <a:ext cx="4023360" cy="201168"/>
+          </a:xfrm>
+          <a:prstGeom prst="rect">
+            <a:avLst/>
+          </a:prstGeom>
+          <a:noFill/>
+        </p:spPr>
+        <p:txBody>
+          <a:bodyPr wrap="square" anchor="t" lIns="27432" rIns="27432" tIns="13716" bIns="13716">
+            <a:noAutofit/>
+          </a:bodyPr>
+          <a:lstStyle/>
+          <a:p>
+            <a:pPr algn="ctr">
+              <a:spcAft>
+                <a:spcPts val="0"/>
+              </a:spcAft>
+              <a:defRPr sz="1400" b="1">
+                <a:solidFill>
+                  <a:srgbClr val="13344F"/>
+                </a:solidFill>
+                <a:latin typeface="Malgun Gothic"/>
+              </a:defRPr>
+            </a:pPr>
+            <a:r>
+              <a:t>grant 대기 중 재발생 → overrun 완화</a:t>
+            </a:r>
+          </a:p>
+        </p:txBody>
+      </p:sp>
+      <p:sp>
+        <p:nvSpPr>
+          <p:cNvPr id="45" name="Rounded Rectangle 44"/>
+          <p:cNvSpPr/>
+          <p:nvPr/>
+        </p:nvSpPr>
+        <p:spPr>
+          <a:xfrm>
+            <a:off x="658368" y="5742432"/>
+            <a:ext cx="10881360" cy="566928"/>
+          </a:xfrm>
+          <a:prstGeom prst="roundRect">
+            <a:avLst/>
+          </a:prstGeom>
+          <a:solidFill>
+            <a:srgbClr val="EBF1F6"/>
+          </a:solidFill>
+          <a:ln>
+            <a:noFill/>
+          </a:ln>
+        </p:spPr>
+        <p:style>
+          <a:lnRef idx="1">
+            <a:schemeClr val="accent1"/>
+          </a:lnRef>
+          <a:fillRef idx="3">
+            <a:schemeClr val="accent1"/>
+          </a:fillRef>
+          <a:effectRef idx="2">
+            <a:schemeClr val="accent1"/>
+          </a:effectRef>
+          <a:fontRef idx="minor">
+            <a:schemeClr val="lt1"/>
+          </a:fontRef>
+        </p:style>
+        <p:txBody>
+          <a:bodyPr rtlCol="0" anchor="ctr"/>
+          <a:lstStyle/>
+          <a:p>
+            <a:pPr algn="ctr"/>
+          </a:p>
+        </p:txBody>
+      </p:sp>
+      <p:sp>
+        <p:nvSpPr>
+          <p:cNvPr id="46" name="Rectangle 45"/>
           <p:cNvSpPr/>
           <p:nvPr/>
         </p:nvSpPr>
@@ -15721,7 +16123,7 @@
       </p:sp>
       <p:sp>
         <p:nvSpPr>
-          <p:cNvPr id="37" name="TextBox 36"/>
+          <p:cNvPr id="47" name="TextBox 46"/>
           <p:cNvSpPr txBox="1"/>
           <p:nvPr/>
         </p:nvSpPr>
@@ -15753,7 +16155,7 @@
               </a:defRPr>
             </a:pPr>
             <a:r>
-              <a:t>bitmap은 serialization을, depth-2는 same-source recurrence를 줄인다</a:t>
+              <a:t>bitmap은 직렬화를, depth-2는 같은 source의 재발생을 줄인다</a:t>
             </a:r>
           </a:p>
         </p:txBody>
@@ -16136,21 +16538,60 @@
               </a:defRPr>
             </a:pPr>
             <a:r>
-              <a:t>CONDITIONAL LANE STEAL</a:t>
-            </a:r>
-          </a:p>
-        </p:txBody>
-      </p:sp>
-      <p:sp>
-        <p:nvSpPr>
-          <p:cNvPr id="11" name="Rounded Rectangle 10"/>
+              <a:t>IDLE-LANE STEAL</a:t>
+            </a:r>
+          </a:p>
+        </p:txBody>
+      </p:sp>
+      <p:sp>
+        <p:nvSpPr>
+          <p:cNvPr id="11" name="TextBox 10"/>
+          <p:cNvSpPr txBox="1"/>
+          <p:nvPr/>
+        </p:nvSpPr>
+        <p:spPr>
+          <a:xfrm>
+            <a:off x="987552" y="2029968"/>
+            <a:ext cx="4645152" cy="237744"/>
+          </a:xfrm>
+          <a:prstGeom prst="rect">
+            <a:avLst/>
+          </a:prstGeom>
+          <a:noFill/>
+        </p:spPr>
+        <p:txBody>
+          <a:bodyPr wrap="square" anchor="t" lIns="27432" rIns="27432" tIns="13716" bIns="13716">
+            <a:noAutofit/>
+          </a:bodyPr>
+          <a:lstStyle/>
+          <a:p>
+            <a:pPr algn="ctr">
+              <a:spcAft>
+                <a:spcPts val="0"/>
+              </a:spcAft>
+              <a:defRPr sz="1500" b="1">
+                <a:solidFill>
+                  <a:srgbClr val="4C6073"/>
+                </a:solidFill>
+                <a:latin typeface="Malgun Gothic"/>
+              </a:defRPr>
+            </a:pPr>
+            <a:r>
+              <a:t>한 class는 busy, 반대 class는 idle</a:t>
+            </a:r>
+          </a:p>
+        </p:txBody>
+      </p:sp>
+      <p:sp>
+        <p:nvSpPr>
+          <p:cNvPr id="12" name="Rounded Rectangle 11"/>
           <p:cNvSpPr/>
           <p:nvPr/>
         </p:nvSpPr>
         <p:spPr>
           <a:xfrm>
-            <a:off x="1005840" y="2057400"/>
-            <a:ext cx="1609344" cy="1051560"/>
+            <a:off x="1124712" y="2468880"/>
+            <a:ext cx="1719072" cy="950976"/>
           </a:xfrm>
           <a:prstGeom prst="roundRect">
             <a:avLst/>
@@ -16188,14 +16629,14 @@
       </p:sp>
       <p:sp>
         <p:nvSpPr>
-          <p:cNvPr id="12" name="TextBox 11"/>
-          <p:cNvSpPr txBox="1"/>
-          <p:nvPr/>
-        </p:nvSpPr>
-        <p:spPr>
-          <a:xfrm>
-            <a:off x="1005840" y="2267712"/>
-            <a:ext cx="1609344" cy="201168"/>
+          <p:cNvPr id="13" name="TextBox 12"/>
+          <p:cNvSpPr txBox="1"/>
+          <p:nvPr/>
+        </p:nvSpPr>
+        <p:spPr>
+          <a:xfrm>
+            <a:off x="1124712" y="2660904"/>
+            <a:ext cx="1719072" cy="182880"/>
           </a:xfrm>
           <a:prstGeom prst="rect">
             <a:avLst/>
@@ -16227,14 +16668,14 @@
       </p:sp>
       <p:sp>
         <p:nvSpPr>
-          <p:cNvPr id="13" name="TextBox 12"/>
-          <p:cNvSpPr txBox="1"/>
-          <p:nvPr/>
-        </p:nvSpPr>
-        <p:spPr>
-          <a:xfrm>
-            <a:off x="1005840" y="2615184"/>
-            <a:ext cx="1609344" cy="256032"/>
+          <p:cNvPr id="14" name="TextBox 13"/>
+          <p:cNvSpPr txBox="1"/>
+          <p:nvPr/>
+        </p:nvSpPr>
+        <p:spPr>
+          <a:xfrm>
+            <a:off x="1124712" y="2971800"/>
+            <a:ext cx="1719072" cy="237744"/>
           </a:xfrm>
           <a:prstGeom prst="rect">
             <a:avLst/>
@@ -16266,14 +16707,14 @@
       </p:sp>
       <p:sp>
         <p:nvSpPr>
-          <p:cNvPr id="14" name="Rounded Rectangle 13"/>
+          <p:cNvPr id="15" name="Rounded Rectangle 14"/>
           <p:cNvSpPr/>
           <p:nvPr/>
         </p:nvSpPr>
         <p:spPr>
           <a:xfrm>
-            <a:off x="3840480" y="2057400"/>
-            <a:ext cx="1609344" cy="1051560"/>
+            <a:off x="3776472" y="2468880"/>
+            <a:ext cx="1719072" cy="950976"/>
           </a:xfrm>
           <a:prstGeom prst="roundRect">
             <a:avLst/>
@@ -16311,14 +16752,14 @@
       </p:sp>
       <p:sp>
         <p:nvSpPr>
-          <p:cNvPr id="15" name="TextBox 14"/>
-          <p:cNvSpPr txBox="1"/>
-          <p:nvPr/>
-        </p:nvSpPr>
-        <p:spPr>
-          <a:xfrm>
-            <a:off x="3840480" y="2267712"/>
-            <a:ext cx="1609344" cy="201168"/>
+          <p:cNvPr id="16" name="TextBox 15"/>
+          <p:cNvSpPr txBox="1"/>
+          <p:nvPr/>
+        </p:nvSpPr>
+        <p:spPr>
+          <a:xfrm>
+            <a:off x="3776472" y="2660904"/>
+            <a:ext cx="1719072" cy="182880"/>
           </a:xfrm>
           <a:prstGeom prst="rect">
             <a:avLst/>
@@ -16343,21 +16784,21 @@
               </a:defRPr>
             </a:pPr>
             <a:r>
-              <a:t>PERIPH.</a:t>
-            </a:r>
-          </a:p>
-        </p:txBody>
-      </p:sp>
-      <p:sp>
-        <p:nvSpPr>
-          <p:cNvPr id="16" name="TextBox 15"/>
-          <p:cNvSpPr txBox="1"/>
-          <p:nvPr/>
-        </p:nvSpPr>
-        <p:spPr>
-          <a:xfrm>
-            <a:off x="3840480" y="2615184"/>
-            <a:ext cx="1609344" cy="256032"/>
+              <a:t>PERIPHERAL</a:t>
+            </a:r>
+          </a:p>
+        </p:txBody>
+      </p:sp>
+      <p:sp>
+        <p:nvSpPr>
+          <p:cNvPr id="17" name="TextBox 16"/>
+          <p:cNvSpPr txBox="1"/>
+          <p:nvPr/>
+        </p:nvSpPr>
+        <p:spPr>
+          <a:xfrm>
+            <a:off x="3776472" y="2971800"/>
+            <a:ext cx="1719072" cy="237744"/>
           </a:xfrm>
           <a:prstGeom prst="rect">
             <a:avLst/>
@@ -16389,16 +16830,16 @@
       </p:sp>
       <p:sp>
         <p:nvSpPr>
-          <p:cNvPr id="17" name="Right Arrow 16"/>
+          <p:cNvPr id="18" name="Left Arrow 17"/>
           <p:cNvSpPr/>
           <p:nvPr/>
         </p:nvSpPr>
         <p:spPr>
           <a:xfrm>
-            <a:off x="3346704" y="2450592"/>
-            <a:ext cx="329184" cy="219456"/>
-          </a:xfrm>
-          <a:prstGeom prst="rightArrow">
+            <a:off x="3136392" y="2834640"/>
+            <a:ext cx="384048" cy="219456"/>
+          </a:xfrm>
+          <a:prstGeom prst="leftArrow">
             <a:avLst/>
           </a:prstGeom>
           <a:solidFill>
@@ -16432,14 +16873,57 @@
       </p:sp>
       <p:sp>
         <p:nvSpPr>
-          <p:cNvPr id="18" name="TextBox 17"/>
-          <p:cNvSpPr txBox="1"/>
-          <p:nvPr/>
-        </p:nvSpPr>
-        <p:spPr>
-          <a:xfrm>
-            <a:off x="987552" y="3730752"/>
-            <a:ext cx="4663440" cy="274320"/>
+          <p:cNvPr id="19" name="Rounded Rectangle 18"/>
+          <p:cNvSpPr/>
+          <p:nvPr/>
+        </p:nvSpPr>
+        <p:spPr>
+          <a:xfrm>
+            <a:off x="1124712" y="3803904"/>
+            <a:ext cx="4370832" cy="621792"/>
+          </a:xfrm>
+          <a:prstGeom prst="roundRect">
+            <a:avLst/>
+          </a:prstGeom>
+          <a:solidFill>
+            <a:srgbClr val="7C4AB8"/>
+          </a:solidFill>
+          <a:ln>
+            <a:noFill/>
+          </a:ln>
+        </p:spPr>
+        <p:style>
+          <a:lnRef idx="1">
+            <a:schemeClr val="accent1"/>
+          </a:lnRef>
+          <a:fillRef idx="3">
+            <a:schemeClr val="accent1"/>
+          </a:fillRef>
+          <a:effectRef idx="2">
+            <a:schemeClr val="accent1"/>
+          </a:effectRef>
+          <a:fontRef idx="minor">
+            <a:schemeClr val="lt1"/>
+          </a:fontRef>
+        </p:style>
+        <p:txBody>
+          <a:bodyPr rtlCol="0" anchor="ctr"/>
+          <a:lstStyle/>
+          <a:p>
+            <a:pPr algn="ctr"/>
+          </a:p>
+        </p:txBody>
+      </p:sp>
+      <p:sp>
+        <p:nvSpPr>
+          <p:cNvPr id="20" name="TextBox 19"/>
+          <p:cNvSpPr txBox="1"/>
+          <p:nvPr/>
+        </p:nvSpPr>
+        <p:spPr>
+          <a:xfrm>
+            <a:off x="1344168" y="4005072"/>
+            <a:ext cx="3931920" cy="219456"/>
           </a:xfrm>
           <a:prstGeom prst="rect">
             <a:avLst/>
@@ -16458,27 +16942,27 @@
               </a:spcAft>
               <a:defRPr sz="1600" b="1">
                 <a:solidFill>
-                  <a:srgbClr val="7C4AB8"/>
-                </a:solidFill>
-                <a:latin typeface="Malgun Gothic"/>
-              </a:defRPr>
-            </a:pPr>
-            <a:r>
-              <a:t>idle lane capacity를 반대 class가 재사용</a:t>
-            </a:r>
-          </a:p>
-        </p:txBody>
-      </p:sp>
-      <p:sp>
-        <p:nvSpPr>
-          <p:cNvPr id="19" name="TextBox 18"/>
-          <p:cNvSpPr txBox="1"/>
-          <p:nvPr/>
-        </p:nvSpPr>
-        <p:spPr>
-          <a:xfrm>
-            <a:off x="987552" y="4224528"/>
-            <a:ext cx="4663440" cy="219456"/>
+                  <a:srgbClr val="FFFFFF"/>
+                </a:solidFill>
+                <a:latin typeface="Malgun Gothic"/>
+              </a:defRPr>
+            </a:pPr>
+            <a:r>
+              <a:t>busy class가 idle lane을 재사용</a:t>
+            </a:r>
+          </a:p>
+        </p:txBody>
+      </p:sp>
+      <p:sp>
+        <p:nvSpPr>
+          <p:cNvPr id="21" name="TextBox 20"/>
+          <p:cNvSpPr txBox="1"/>
+          <p:nvPr/>
+        </p:nvSpPr>
+        <p:spPr>
+          <a:xfrm>
+            <a:off x="987552" y="4645152"/>
+            <a:ext cx="4663440" cy="201168"/>
           </a:xfrm>
           <a:prstGeom prst="rect">
             <a:avLst/>
@@ -16503,14 +16987,14 @@
               </a:defRPr>
             </a:pPr>
             <a:r>
-              <a:t>global fairness 수치는 별도</a:t>
-            </a:r>
-          </a:p>
-        </p:txBody>
-      </p:sp>
-      <p:sp>
-        <p:nvSpPr>
-          <p:cNvPr id="20" name="Rounded Rectangle 19"/>
+              <a:t>capacity 활용도 향상 · fairness 정량 평가는 별도</a:t>
+            </a:r>
+          </a:p>
+        </p:txBody>
+      </p:sp>
+      <p:sp>
+        <p:nvSpPr>
+          <p:cNvPr id="22" name="Rounded Rectangle 21"/>
           <p:cNvSpPr/>
           <p:nvPr/>
         </p:nvSpPr>
@@ -16555,7 +17039,7 @@
       </p:sp>
       <p:sp>
         <p:nvSpPr>
-          <p:cNvPr id="21" name="TextBox 20"/>
+          <p:cNvPr id="23" name="TextBox 22"/>
           <p:cNvSpPr txBox="1"/>
           <p:nvPr/>
         </p:nvSpPr>
@@ -16594,7 +17078,7 @@
       </p:sp>
       <p:sp>
         <p:nvSpPr>
-          <p:cNvPr id="22" name="TextBox 21"/>
+          <p:cNvPr id="24" name="TextBox 23"/>
           <p:cNvSpPr txBox="1"/>
           <p:nvPr/>
         </p:nvSpPr>
@@ -16633,14 +17117,53 @@
       </p:sp>
       <p:sp>
         <p:nvSpPr>
-          <p:cNvPr id="23" name="Rounded Rectangle 22"/>
+          <p:cNvPr id="25" name="TextBox 24"/>
+          <p:cNvSpPr txBox="1"/>
+          <p:nvPr/>
+        </p:nvSpPr>
+        <p:spPr>
+          <a:xfrm>
+            <a:off x="6565392" y="2029968"/>
+            <a:ext cx="4645152" cy="237744"/>
+          </a:xfrm>
+          <a:prstGeom prst="rect">
+            <a:avLst/>
+          </a:prstGeom>
+          <a:noFill/>
+        </p:spPr>
+        <p:txBody>
+          <a:bodyPr wrap="square" anchor="t" lIns="27432" rIns="27432" tIns="13716" bIns="13716">
+            <a:noAutofit/>
+          </a:bodyPr>
+          <a:lstStyle/>
+          <a:p>
+            <a:pPr algn="ctr">
+              <a:spcAft>
+                <a:spcPts val="0"/>
+              </a:spcAft>
+              <a:defRPr sz="1500" b="1">
+                <a:solidFill>
+                  <a:srgbClr val="4C6073"/>
+                </a:solidFill>
+                <a:latin typeface="Malgun Gothic"/>
+              </a:defRPr>
+            </a:pPr>
+            <a:r>
+              <a:t>address·polarity를 같은 source slot에서 처리</a:t>
+            </a:r>
+          </a:p>
+        </p:txBody>
+      </p:sp>
+      <p:sp>
+        <p:nvSpPr>
+          <p:cNvPr id="26" name="Rounded Rectangle 25"/>
           <p:cNvSpPr/>
           <p:nvPr/>
         </p:nvSpPr>
         <p:spPr>
           <a:xfrm>
-            <a:off x="6601968" y="1956816"/>
-            <a:ext cx="4572000" cy="713232"/>
+            <a:off x="6601968" y="2468880"/>
+            <a:ext cx="4572000" cy="676656"/>
           </a:xfrm>
           <a:prstGeom prst="roundRect">
             <a:avLst/>
@@ -16678,13 +17201,13 @@
       </p:sp>
       <p:sp>
         <p:nvSpPr>
-          <p:cNvPr id="24" name="TextBox 23"/>
-          <p:cNvSpPr txBox="1"/>
-          <p:nvPr/>
-        </p:nvSpPr>
-        <p:spPr>
-          <a:xfrm>
-            <a:off x="6821424" y="2176272"/>
+          <p:cNvPr id="27" name="TextBox 26"/>
+          <p:cNvSpPr txBox="1"/>
+          <p:nvPr/>
+        </p:nvSpPr>
+        <p:spPr>
+          <a:xfrm>
+            <a:off x="6821424" y="2706624"/>
             <a:ext cx="347472" cy="201168"/>
           </a:xfrm>
           <a:prstGeom prst="rect">
@@ -16717,13 +17240,13 @@
       </p:sp>
       <p:sp>
         <p:nvSpPr>
-          <p:cNvPr id="25" name="TextBox 24"/>
-          <p:cNvSpPr txBox="1"/>
-          <p:nvPr/>
-        </p:nvSpPr>
-        <p:spPr>
-          <a:xfrm>
-            <a:off x="7370064" y="2176272"/>
+          <p:cNvPr id="28" name="TextBox 27"/>
+          <p:cNvSpPr txBox="1"/>
+          <p:nvPr/>
+        </p:nvSpPr>
+        <p:spPr>
+          <a:xfrm>
+            <a:off x="7370064" y="2706624"/>
             <a:ext cx="1901952" cy="201168"/>
           </a:xfrm>
           <a:prstGeom prst="rect">
@@ -16756,13 +17279,13 @@
       </p:sp>
       <p:sp>
         <p:nvSpPr>
-          <p:cNvPr id="26" name="TextBox 25"/>
-          <p:cNvSpPr txBox="1"/>
-          <p:nvPr/>
-        </p:nvSpPr>
-        <p:spPr>
-          <a:xfrm>
-            <a:off x="9656064" y="2176272"/>
+          <p:cNvPr id="29" name="TextBox 28"/>
+          <p:cNvSpPr txBox="1"/>
+          <p:nvPr/>
+        </p:nvSpPr>
+        <p:spPr>
+          <a:xfrm>
+            <a:off x="9656064" y="2706624"/>
             <a:ext cx="1188720" cy="201168"/>
           </a:xfrm>
           <a:prstGeom prst="rect">
@@ -16795,14 +17318,14 @@
       </p:sp>
       <p:sp>
         <p:nvSpPr>
-          <p:cNvPr id="27" name="Rounded Rectangle 26"/>
+          <p:cNvPr id="30" name="Rounded Rectangle 29"/>
           <p:cNvSpPr/>
           <p:nvPr/>
         </p:nvSpPr>
         <p:spPr>
           <a:xfrm>
-            <a:off x="6601968" y="2916936"/>
-            <a:ext cx="4572000" cy="713232"/>
+            <a:off x="6601968" y="3401568"/>
+            <a:ext cx="4572000" cy="676656"/>
           </a:xfrm>
           <a:prstGeom prst="roundRect">
             <a:avLst/>
@@ -16840,13 +17363,13 @@
       </p:sp>
       <p:sp>
         <p:nvSpPr>
-          <p:cNvPr id="28" name="TextBox 27"/>
-          <p:cNvSpPr txBox="1"/>
-          <p:nvPr/>
-        </p:nvSpPr>
-        <p:spPr>
-          <a:xfrm>
-            <a:off x="6821424" y="3136392"/>
+          <p:cNvPr id="31" name="TextBox 30"/>
+          <p:cNvSpPr txBox="1"/>
+          <p:nvPr/>
+        </p:nvSpPr>
+        <p:spPr>
+          <a:xfrm>
+            <a:off x="6821424" y="3639312"/>
             <a:ext cx="347472" cy="201168"/>
           </a:xfrm>
           <a:prstGeom prst="rect">
@@ -16879,13 +17402,13 @@
       </p:sp>
       <p:sp>
         <p:nvSpPr>
-          <p:cNvPr id="29" name="TextBox 28"/>
-          <p:cNvSpPr txBox="1"/>
-          <p:nvPr/>
-        </p:nvSpPr>
-        <p:spPr>
-          <a:xfrm>
-            <a:off x="7370064" y="3136392"/>
+          <p:cNvPr id="32" name="TextBox 31"/>
+          <p:cNvSpPr txBox="1"/>
+          <p:nvPr/>
+        </p:nvSpPr>
+        <p:spPr>
+          <a:xfrm>
+            <a:off x="7370064" y="3639312"/>
             <a:ext cx="1901952" cy="201168"/>
           </a:xfrm>
           <a:prstGeom prst="rect">
@@ -16918,13 +17441,13 @@
       </p:sp>
       <p:sp>
         <p:nvSpPr>
-          <p:cNvPr id="30" name="TextBox 29"/>
-          <p:cNvSpPr txBox="1"/>
-          <p:nvPr/>
-        </p:nvSpPr>
-        <p:spPr>
-          <a:xfrm>
-            <a:off x="9656064" y="3136392"/>
+          <p:cNvPr id="33" name="TextBox 32"/>
+          <p:cNvSpPr txBox="1"/>
+          <p:nvPr/>
+        </p:nvSpPr>
+        <p:spPr>
+          <a:xfrm>
+            <a:off x="9656064" y="3639312"/>
             <a:ext cx="1188720" cy="201168"/>
           </a:xfrm>
           <a:prstGeom prst="rect">
@@ -16957,14 +17480,57 @@
       </p:sp>
       <p:sp>
         <p:nvSpPr>
-          <p:cNvPr id="31" name="TextBox 30"/>
-          <p:cNvSpPr txBox="1"/>
-          <p:nvPr/>
-        </p:nvSpPr>
-        <p:spPr>
-          <a:xfrm>
-            <a:off x="6583680" y="4242816"/>
-            <a:ext cx="4608576" cy="237744"/>
+          <p:cNvPr id="34" name="Rounded Rectangle 33"/>
+          <p:cNvSpPr/>
+          <p:nvPr/>
+        </p:nvSpPr>
+        <p:spPr>
+          <a:xfrm>
+            <a:off x="6601968" y="4443984"/>
+            <a:ext cx="4572000" cy="438912"/>
+          </a:xfrm>
+          <a:prstGeom prst="roundRect">
+            <a:avLst/>
+          </a:prstGeom>
+          <a:solidFill>
+            <a:srgbClr val="2563EB"/>
+          </a:solidFill>
+          <a:ln>
+            <a:noFill/>
+          </a:ln>
+        </p:spPr>
+        <p:style>
+          <a:lnRef idx="1">
+            <a:schemeClr val="accent1"/>
+          </a:lnRef>
+          <a:fillRef idx="3">
+            <a:schemeClr val="accent1"/>
+          </a:fillRef>
+          <a:effectRef idx="2">
+            <a:schemeClr val="accent1"/>
+          </a:effectRef>
+          <a:fontRef idx="minor">
+            <a:schemeClr val="lt1"/>
+          </a:fontRef>
+        </p:style>
+        <p:txBody>
+          <a:bodyPr rtlCol="0" anchor="ctr"/>
+          <a:lstStyle/>
+          <a:p>
+            <a:pPr algn="ctr"/>
+          </a:p>
+        </p:txBody>
+      </p:sp>
+      <p:sp>
+        <p:nvSpPr>
+          <p:cNvPr id="35" name="TextBox 34"/>
+          <p:cNvSpPr txBox="1"/>
+          <p:nvPr/>
+        </p:nvSpPr>
+        <p:spPr>
+          <a:xfrm>
+            <a:off x="6821424" y="4572000"/>
+            <a:ext cx="4133087" cy="182880"/>
           </a:xfrm>
           <a:prstGeom prst="rect">
             <a:avLst/>
@@ -16981,22 +17547,22 @@
               <a:spcAft>
                 <a:spcPts val="0"/>
               </a:spcAft>
-              <a:defRPr sz="1500" b="1">
-                <a:solidFill>
-                  <a:srgbClr val="2563EB"/>
-                </a:solidFill>
-                <a:latin typeface="Malgun Gothic"/>
-              </a:defRPr>
-            </a:pPr>
-            <a:r>
-              <a:t>address와 polarity를 같은 slot에서 push / pop</a:t>
-            </a:r>
-          </a:p>
-        </p:txBody>
-      </p:sp>
-      <p:sp>
-        <p:nvSpPr>
-          <p:cNvPr id="32" name="Rounded Rectangle 31"/>
+              <a:defRPr sz="1400" b="1">
+                <a:solidFill>
+                  <a:srgbClr val="FFFFFF"/>
+                </a:solidFill>
+                <a:latin typeface="Malgun Gothic"/>
+              </a:defRPr>
+            </a:pPr>
+            <a:r>
+              <a:t>동시 push · 동시 pop · 의미 보존</a:t>
+            </a:r>
+          </a:p>
+        </p:txBody>
+      </p:sp>
+      <p:sp>
+        <p:nvSpPr>
+          <p:cNvPr id="36" name="Rounded Rectangle 35"/>
           <p:cNvSpPr/>
           <p:nvPr/>
         </p:nvSpPr>
@@ -17039,7 +17605,7 @@
       </p:sp>
       <p:sp>
         <p:nvSpPr>
-          <p:cNvPr id="33" name="Rectangle 32"/>
+          <p:cNvPr id="37" name="Rectangle 36"/>
           <p:cNvSpPr/>
           <p:nvPr/>
         </p:nvSpPr>
@@ -17082,7 +17648,7 @@
       </p:sp>
       <p:sp>
         <p:nvSpPr>
-          <p:cNvPr id="34" name="TextBox 33"/>
+          <p:cNvPr id="38" name="TextBox 37"/>
           <p:cNvSpPr txBox="1"/>
           <p:nvPr/>
         </p:nvSpPr>
@@ -17114,7 +17680,7 @@
               </a:defRPr>
             </a:pPr>
             <a:r>
-              <a:t>steal은 capacity 낭비를 줄이고, lockstep은 selected-event 의미를 보존한다</a:t>
+              <a:t>steal은 capacity 낭비를 줄이고, lockstep은 selected event의 의미를 보존한다</a:t>
             </a:r>
           </a:p>
         </p:txBody>

</xml_diff>